<commit_message>
Add 14 AI Use Cases catalog slide to NCP Solver deck
New slide 3 lists all 14 seeded AI use cases (title, tier, stage/module,
status, description) as a POWERACT-branded table, distinguishing the 9
in-production use cases from the 5 roadmap entries. Closing slide moves
to position 4.

Co-Authored-By: Claude Sonnet 5 <noreply@anthropic.com>
Claude-Session: https://claude.ai/code/session_01JawUecr4zdt3wAKeYty8P7
</commit_message>
<xml_diff>
--- a/ncp-solver/docs/NCP_Solver_Presentation.pptx
+++ b/ncp-solver/docs/NCP_Solver_Presentation.pptx
@@ -8,9 +8,10 @@
     <p:sldId id="256" r:id="rId2"/>
     <p:sldId id="257" r:id="rId3"/>
     <p:sldId id="258" r:id="rId4"/>
+    <p:sldId id="259" r:id="rId5"/>
   </p:sldIdLst>
   <p:notesMasterIdLst>
-    <p:notesMasterId r:id="rId5"/>
+    <p:notesMasterId r:id="rId6"/>
   </p:notesMasterIdLst>
   <p:sldSz cx="12191695" cy="6858000"/>
   <p:notesSz cx="6858000" cy="12191695"/>
@@ -722,6 +723,94 @@
 </p:notes>
 </file>
 
+<file path=ppt/notesSlides/notesSlide4.xml><?xml version="1.0" encoding="utf-8"?>
+<p:notes xmlns:a="http://schemas.openxmlformats.org/drawingml/2006/main" xmlns:r="http://schemas.openxmlformats.org/officeDocument/2006/relationships" xmlns:p="http://schemas.openxmlformats.org/presentationml/2006/main">
+  <p:cSld>
+    <p:spTree>
+      <p:nvGrpSpPr>
+        <p:cNvPr id="1" name=""/>
+        <p:cNvGrpSpPr/>
+        <p:nvPr/>
+      </p:nvGrpSpPr>
+      <p:grpSpPr>
+        <a:xfrm>
+          <a:off x="0" y="0"/>
+          <a:ext cx="0" cy="0"/>
+          <a:chOff x="0" y="0"/>
+          <a:chExt cx="0" cy="0"/>
+        </a:xfrm>
+      </p:grpSpPr>
+      <p:sp>
+        <p:nvSpPr>
+          <p:cNvPr id="2" name="Slide Image Placeholder 1"/>
+          <p:cNvSpPr>
+            <a:spLocks noGrp="1" noRot="1" noChangeAspect="1"/>
+          </p:cNvSpPr>
+          <p:nvPr>
+            <p:ph type="sldImg"/>
+          </p:nvPr>
+        </p:nvSpPr>
+        <p:spPr/>
+      </p:sp>
+      <p:sp>
+        <p:nvSpPr>
+          <p:cNvPr id="3" name="Notes Placeholder 2"/>
+          <p:cNvSpPr>
+            <a:spLocks noGrp="1"/>
+          </p:cNvSpPr>
+          <p:nvPr>
+            <p:ph type="body" idx="1"/>
+          </p:nvPr>
+        </p:nvSpPr>
+        <p:spPr/>
+        <p:txBody>
+          <a:bodyPr/>
+          <a:lstStyle/>
+          <a:p>
+            <a:r>
+              <a:rPr lang="en-US" dirty="0"/>
+              <a:t/>
+            </a:r>
+            <a:endParaRPr lang="en-US" dirty="0"/>
+          </a:p>
+        </p:txBody>
+      </p:sp>
+      <p:sp>
+        <p:nvSpPr>
+          <p:cNvPr id="4" name="Slide Number Placeholder 3"/>
+          <p:cNvSpPr>
+            <a:spLocks noGrp="1"/>
+          </p:cNvSpPr>
+          <p:nvPr>
+            <p:ph type="sldNum" sz="quarter" idx="10"/>
+          </p:nvPr>
+        </p:nvSpPr>
+        <p:spPr/>
+        <p:txBody>
+          <a:bodyPr/>
+          <a:lstStyle/>
+          <a:p>
+            <a:fld id="{F7021451-1387-4CA6-816F-3879F97B5CBC}" type="slidenum">
+              <a:rPr lang="en-US"/>
+              <a:t>4</a:t>
+            </a:fld>
+            <a:endParaRPr lang="en-US"/>
+          </a:p>
+        </p:txBody>
+      </p:sp>
+    </p:spTree>
+    <p:extLst>
+      <p:ext uri="{BB962C8B-B14F-4D97-AF65-F5344CB8AC3E}">
+        <p14:creationId xmlns:p14="http://schemas.microsoft.com/office/powerpoint/2010/main" val="1024086991"/>
+      </p:ext>
+    </p:extLst>
+  </p:cSld>
+  <p:clrMapOvr>
+    <a:masterClrMapping/>
+  </p:clrMapOvr>
+</p:notes>
+</file>
+
 <file path=ppt/slideLayouts/slideLayout1.xml><?xml version="1.0" encoding="utf-8"?>
 <p:sldLayout xmlns:a="http://schemas.openxmlformats.org/drawingml/2006/main" xmlns:r="http://schemas.openxmlformats.org/officeDocument/2006/relationships" xmlns:p="http://schemas.openxmlformats.org/presentationml/2006/main" preserve="1">
   <p:cSld name="DEFAULT">
@@ -3091,6 +3180,4242 @@
     <p:bg>
       <p:bgPr>
         <a:solidFill>
+          <a:srgbClr val="FDFDFC"/>
+        </a:solidFill>
+      </p:bgPr>
+    </p:bg>
+    <p:spTree>
+      <p:nvGrpSpPr>
+        <p:cNvPr id="1" name=""/>
+        <p:cNvGrpSpPr/>
+        <p:nvPr/>
+      </p:nvGrpSpPr>
+      <p:grpSpPr>
+        <a:xfrm>
+          <a:off x="0" y="0"/>
+          <a:ext cx="0" cy="0"/>
+          <a:chOff x="0" y="0"/>
+          <a:chExt cx="0" cy="0"/>
+        </a:xfrm>
+      </p:grpSpPr>
+      <p:sp>
+        <p:nvSpPr>
+          <p:cNvPr id="2" name="Text 0"/>
+          <p:cNvSpPr txBox="1"/>
+          <p:nvPr/>
+        </p:nvSpPr>
+        <p:spPr>
+          <a:xfrm>
+            <a:off x="548640" y="411480"/>
+            <a:ext cx="9144000" cy="320040"/>
+          </a:xfrm>
+          <a:prstGeom prst="rect">
+            <a:avLst/>
+          </a:prstGeom>
+          <a:noFill/>
+          <a:ln/>
+        </p:spPr>
+        <p:txBody>
+          <a:bodyPr wrap="square" lIns="0" tIns="0" rIns="0" bIns="0" rtlCol="0" anchor="ctr"/>
+          <a:lstStyle/>
+          <a:p>
+            <a:pPr algn="l" indent="0" marL="0">
+              <a:buNone/>
+            </a:pPr>
+            <a:r>
+              <a:rPr lang="en-US" sz="1200" b="1" spc="200" kern="0" dirty="0">
+                <a:solidFill>
+                  <a:srgbClr val="E07B00"/>
+                </a:solidFill>
+                <a:latin typeface="Calibri" pitchFamily="34" charset="0"/>
+                <a:ea typeface="Calibri" pitchFamily="34" charset="-122"/>
+                <a:cs typeface="Calibri" pitchFamily="34" charset="-120"/>
+              </a:rPr>
+              <a:t>THE GOVERNED AI USE CASE LIBRARY</a:t>
+            </a:r>
+            <a:endParaRPr lang="en-US" sz="1200" dirty="0"/>
+          </a:p>
+        </p:txBody>
+      </p:sp>
+      <p:sp>
+        <p:nvSpPr>
+          <p:cNvPr id="3" name="Text 1"/>
+          <p:cNvSpPr txBox="1"/>
+          <p:nvPr/>
+        </p:nvSpPr>
+        <p:spPr>
+          <a:xfrm>
+            <a:off x="548640" y="713232"/>
+            <a:ext cx="10515600" cy="548640"/>
+          </a:xfrm>
+          <a:prstGeom prst="rect">
+            <a:avLst/>
+          </a:prstGeom>
+          <a:noFill/>
+          <a:ln/>
+        </p:spPr>
+        <p:txBody>
+          <a:bodyPr wrap="square" lIns="0" tIns="0" rIns="0" bIns="0" rtlCol="0" anchor="ctr"/>
+          <a:lstStyle/>
+          <a:p>
+            <a:pPr indent="0" marL="0">
+              <a:buNone/>
+            </a:pPr>
+            <a:r>
+              <a:rPr lang="en-US" sz="2800" b="1" dirty="0">
+                <a:solidFill>
+                  <a:srgbClr val="3A3A3C"/>
+                </a:solidFill>
+                <a:latin typeface="Cambria" pitchFamily="34" charset="0"/>
+                <a:ea typeface="Cambria" pitchFamily="34" charset="-122"/>
+                <a:cs typeface="Cambria" pitchFamily="34" charset="-120"/>
+              </a:rPr>
+              <a:t>14 AI Use Cases, Catalog to Roadmap</a:t>
+            </a:r>
+            <a:endParaRPr lang="en-US" sz="2800" dirty="0"/>
+          </a:p>
+        </p:txBody>
+      </p:sp>
+      <p:graphicFrame>
+        <p:nvGraphicFramePr>
+          <p:cNvPr id="4" name="Table 0"/>
+          <p:cNvGraphicFramePr>
+            <a:graphicFrameLocks noGrp="1"/>
+          </p:cNvGraphicFramePr>
+          <p:nvPr>
+            <p:extLst>
+              <p:ext uri="{D42A27DB-BD31-4B8C-83A1-F6EECF244321}">
+                <p14:modId xmlns:p14="http://schemas.microsoft.com/office/powerpoint/2010/main" val="1579011935"/>
+              </p:ext>
+            </p:extLst>
+          </p:nvPr>
+        </p:nvGraphicFramePr>
+        <p:xfrm>
+          <a:off x="548640" y="1417320"/>
+          <a:ext cx="11094415" cy="914400"/>
+        </p:xfrm>
+        <a:graphic>
+          <a:graphicData uri="http://schemas.openxmlformats.org/drawingml/2006/table">
+            <a:tbl>
+              <a:tblPr/>
+              <a:tblGrid>
+                <a:gridCol w="365760"/>
+                <a:gridCol w="2377440"/>
+                <a:gridCol w="914400"/>
+                <a:gridCol w="1188720"/>
+                <a:gridCol w="914400"/>
+                <a:gridCol w="5333695"/>
+              </a:tblGrid>
+              <a:tr h="310896">
+                <a:tc>
+                  <a:txBody>
+                    <a:bodyPr/>
+                    <a:lstStyle/>
+                    <a:p>
+                      <a:pPr algn="ctr" indent="0" marL="0">
+                        <a:buNone/>
+                      </a:pPr>
+                      <a:r>
+                        <a:rPr lang="en-US" sz="950" b="1" dirty="0">
+                          <a:solidFill>
+                            <a:srgbClr val="FFFFFF"/>
+                          </a:solidFill>
+                          <a:latin typeface="Calibri" pitchFamily="34" charset="0"/>
+                          <a:ea typeface="Calibri" pitchFamily="34" charset="-122"/>
+                          <a:cs typeface="Calibri" pitchFamily="34" charset="-120"/>
+                        </a:rPr>
+                        <a:t>#</a:t>
+                      </a:r>
+                      <a:endParaRPr lang="en-US" sz="950" dirty="0">
+                        <a:latin typeface="Calibri" charset="0"/>
+                        <a:ea typeface="Calibri" charset="0"/>
+                        <a:cs typeface="Calibri" charset="0"/>
+                      </a:endParaRPr>
+                    </a:p>
+                  </a:txBody>
+                  <a:tcPr marL="91440" marR="91440" marT="45720" marB="45720" anchor="ctr">
+                    <a:lnL w="0" cap="flat" cmpd="sng" algn="ctr">
+                      <a:noFill/>
+                    </a:lnL>
+                    <a:lnR w="0" cap="flat" cmpd="sng" algn="ctr">
+                      <a:noFill/>
+                    </a:lnR>
+                    <a:lnT w="0" cap="flat" cmpd="sng" algn="ctr">
+                      <a:noFill/>
+                    </a:lnT>
+                    <a:lnB w="0" cap="flat" cmpd="sng" algn="ctr">
+                      <a:noFill/>
+                    </a:lnB>
+                    <a:solidFill>
+                      <a:srgbClr val="F8931D"/>
+                    </a:solidFill>
+                  </a:tcPr>
+                </a:tc>
+                <a:tc>
+                  <a:txBody>
+                    <a:bodyPr/>
+                    <a:lstStyle/>
+                    <a:p>
+                      <a:pPr indent="0" marL="0">
+                        <a:buNone/>
+                      </a:pPr>
+                      <a:r>
+                        <a:rPr lang="en-US" sz="950" b="1" dirty="0">
+                          <a:solidFill>
+                            <a:srgbClr val="FFFFFF"/>
+                          </a:solidFill>
+                          <a:latin typeface="Calibri" pitchFamily="34" charset="0"/>
+                          <a:ea typeface="Calibri" pitchFamily="34" charset="-122"/>
+                          <a:cs typeface="Calibri" pitchFamily="34" charset="-120"/>
+                        </a:rPr>
+                        <a:t>AI Use Case</a:t>
+                      </a:r>
+                      <a:endParaRPr lang="en-US" sz="950" dirty="0">
+                        <a:latin typeface="Calibri" charset="0"/>
+                        <a:ea typeface="Calibri" charset="0"/>
+                        <a:cs typeface="Calibri" charset="0"/>
+                      </a:endParaRPr>
+                    </a:p>
+                  </a:txBody>
+                  <a:tcPr marL="91440" marR="91440" marT="45720" marB="45720" anchor="ctr">
+                    <a:lnL w="0" cap="flat" cmpd="sng" algn="ctr">
+                      <a:noFill/>
+                    </a:lnL>
+                    <a:lnR w="0" cap="flat" cmpd="sng" algn="ctr">
+                      <a:noFill/>
+                    </a:lnR>
+                    <a:lnT w="0" cap="flat" cmpd="sng" algn="ctr">
+                      <a:noFill/>
+                    </a:lnT>
+                    <a:lnB w="0" cap="flat" cmpd="sng" algn="ctr">
+                      <a:noFill/>
+                    </a:lnB>
+                    <a:solidFill>
+                      <a:srgbClr val="F8931D"/>
+                    </a:solidFill>
+                  </a:tcPr>
+                </a:tc>
+                <a:tc>
+                  <a:txBody>
+                    <a:bodyPr/>
+                    <a:lstStyle/>
+                    <a:p>
+                      <a:pPr indent="0" marL="0">
+                        <a:buNone/>
+                      </a:pPr>
+                      <a:r>
+                        <a:rPr lang="en-US" sz="950" b="1" dirty="0">
+                          <a:solidFill>
+                            <a:srgbClr val="FFFFFF"/>
+                          </a:solidFill>
+                          <a:latin typeface="Calibri" pitchFamily="34" charset="0"/>
+                          <a:ea typeface="Calibri" pitchFamily="34" charset="-122"/>
+                          <a:cs typeface="Calibri" pitchFamily="34" charset="-120"/>
+                        </a:rPr>
+                        <a:t>Tier</a:t>
+                      </a:r>
+                      <a:endParaRPr lang="en-US" sz="950" dirty="0">
+                        <a:latin typeface="Calibri" charset="0"/>
+                        <a:ea typeface="Calibri" charset="0"/>
+                        <a:cs typeface="Calibri" charset="0"/>
+                      </a:endParaRPr>
+                    </a:p>
+                  </a:txBody>
+                  <a:tcPr marL="91440" marR="91440" marT="45720" marB="45720" anchor="ctr">
+                    <a:lnL w="0" cap="flat" cmpd="sng" algn="ctr">
+                      <a:noFill/>
+                    </a:lnL>
+                    <a:lnR w="0" cap="flat" cmpd="sng" algn="ctr">
+                      <a:noFill/>
+                    </a:lnR>
+                    <a:lnT w="0" cap="flat" cmpd="sng" algn="ctr">
+                      <a:noFill/>
+                    </a:lnT>
+                    <a:lnB w="0" cap="flat" cmpd="sng" algn="ctr">
+                      <a:noFill/>
+                    </a:lnB>
+                    <a:solidFill>
+                      <a:srgbClr val="F8931D"/>
+                    </a:solidFill>
+                  </a:tcPr>
+                </a:tc>
+                <a:tc>
+                  <a:txBody>
+                    <a:bodyPr/>
+                    <a:lstStyle/>
+                    <a:p>
+                      <a:pPr indent="0" marL="0">
+                        <a:buNone/>
+                      </a:pPr>
+                      <a:r>
+                        <a:rPr lang="en-US" sz="950" b="1" dirty="0">
+                          <a:solidFill>
+                            <a:srgbClr val="FFFFFF"/>
+                          </a:solidFill>
+                          <a:latin typeface="Calibri" pitchFamily="34" charset="0"/>
+                          <a:ea typeface="Calibri" pitchFamily="34" charset="-122"/>
+                          <a:cs typeface="Calibri" pitchFamily="34" charset="-120"/>
+                        </a:rPr>
+                        <a:t>Stage / Module</a:t>
+                      </a:r>
+                      <a:endParaRPr lang="en-US" sz="950" dirty="0">
+                        <a:latin typeface="Calibri" charset="0"/>
+                        <a:ea typeface="Calibri" charset="0"/>
+                        <a:cs typeface="Calibri" charset="0"/>
+                      </a:endParaRPr>
+                    </a:p>
+                  </a:txBody>
+                  <a:tcPr marL="91440" marR="91440" marT="45720" marB="45720" anchor="ctr">
+                    <a:lnL w="0" cap="flat" cmpd="sng" algn="ctr">
+                      <a:noFill/>
+                    </a:lnL>
+                    <a:lnR w="0" cap="flat" cmpd="sng" algn="ctr">
+                      <a:noFill/>
+                    </a:lnR>
+                    <a:lnT w="0" cap="flat" cmpd="sng" algn="ctr">
+                      <a:noFill/>
+                    </a:lnT>
+                    <a:lnB w="0" cap="flat" cmpd="sng" algn="ctr">
+                      <a:noFill/>
+                    </a:lnB>
+                    <a:solidFill>
+                      <a:srgbClr val="F8931D"/>
+                    </a:solidFill>
+                  </a:tcPr>
+                </a:tc>
+                <a:tc>
+                  <a:txBody>
+                    <a:bodyPr/>
+                    <a:lstStyle/>
+                    <a:p>
+                      <a:pPr indent="0" marL="0">
+                        <a:buNone/>
+                      </a:pPr>
+                      <a:r>
+                        <a:rPr lang="en-US" sz="950" b="1" dirty="0">
+                          <a:solidFill>
+                            <a:srgbClr val="FFFFFF"/>
+                          </a:solidFill>
+                          <a:latin typeface="Calibri" pitchFamily="34" charset="0"/>
+                          <a:ea typeface="Calibri" pitchFamily="34" charset="-122"/>
+                          <a:cs typeface="Calibri" pitchFamily="34" charset="-120"/>
+                        </a:rPr>
+                        <a:t>Status</a:t>
+                      </a:r>
+                      <a:endParaRPr lang="en-US" sz="950" dirty="0">
+                        <a:latin typeface="Calibri" charset="0"/>
+                        <a:ea typeface="Calibri" charset="0"/>
+                        <a:cs typeface="Calibri" charset="0"/>
+                      </a:endParaRPr>
+                    </a:p>
+                  </a:txBody>
+                  <a:tcPr marL="91440" marR="91440" marT="45720" marB="45720" anchor="ctr">
+                    <a:lnL w="0" cap="flat" cmpd="sng" algn="ctr">
+                      <a:noFill/>
+                    </a:lnL>
+                    <a:lnR w="0" cap="flat" cmpd="sng" algn="ctr">
+                      <a:noFill/>
+                    </a:lnR>
+                    <a:lnT w="0" cap="flat" cmpd="sng" algn="ctr">
+                      <a:noFill/>
+                    </a:lnT>
+                    <a:lnB w="0" cap="flat" cmpd="sng" algn="ctr">
+                      <a:noFill/>
+                    </a:lnB>
+                    <a:solidFill>
+                      <a:srgbClr val="F8931D"/>
+                    </a:solidFill>
+                  </a:tcPr>
+                </a:tc>
+                <a:tc>
+                  <a:txBody>
+                    <a:bodyPr/>
+                    <a:lstStyle/>
+                    <a:p>
+                      <a:pPr indent="0" marL="0">
+                        <a:buNone/>
+                      </a:pPr>
+                      <a:r>
+                        <a:rPr lang="en-US" sz="950" b="1" dirty="0">
+                          <a:solidFill>
+                            <a:srgbClr val="FFFFFF"/>
+                          </a:solidFill>
+                          <a:latin typeface="Calibri" pitchFamily="34" charset="0"/>
+                          <a:ea typeface="Calibri" pitchFamily="34" charset="-122"/>
+                          <a:cs typeface="Calibri" pitchFamily="34" charset="-120"/>
+                        </a:rPr>
+                        <a:t>What It Does</a:t>
+                      </a:r>
+                      <a:endParaRPr lang="en-US" sz="950" dirty="0">
+                        <a:latin typeface="Calibri" charset="0"/>
+                        <a:ea typeface="Calibri" charset="0"/>
+                        <a:cs typeface="Calibri" charset="0"/>
+                      </a:endParaRPr>
+                    </a:p>
+                  </a:txBody>
+                  <a:tcPr marL="91440" marR="91440" marT="45720" marB="45720" anchor="ctr">
+                    <a:lnL w="0" cap="flat" cmpd="sng" algn="ctr">
+                      <a:noFill/>
+                    </a:lnL>
+                    <a:lnR w="0" cap="flat" cmpd="sng" algn="ctr">
+                      <a:noFill/>
+                    </a:lnR>
+                    <a:lnT w="0" cap="flat" cmpd="sng" algn="ctr">
+                      <a:noFill/>
+                    </a:lnT>
+                    <a:lnB w="0" cap="flat" cmpd="sng" algn="ctr">
+                      <a:noFill/>
+                    </a:lnB>
+                    <a:solidFill>
+                      <a:srgbClr val="F8931D"/>
+                    </a:solidFill>
+                  </a:tcPr>
+                </a:tc>
+              </a:tr>
+              <a:tr h="290779">
+                <a:tc>
+                  <a:txBody>
+                    <a:bodyPr/>
+                    <a:lstStyle/>
+                    <a:p>
+                      <a:pPr algn="ctr" indent="0" marL="0">
+                        <a:buNone/>
+                      </a:pPr>
+                      <a:r>
+                        <a:rPr lang="en-US" sz="800" dirty="0">
+                          <a:solidFill>
+                            <a:srgbClr val="808184"/>
+                          </a:solidFill>
+                          <a:latin typeface="Calibri" pitchFamily="34" charset="0"/>
+                          <a:ea typeface="Calibri" pitchFamily="34" charset="-122"/>
+                          <a:cs typeface="Calibri" pitchFamily="34" charset="-120"/>
+                        </a:rPr>
+                        <a:t>1</a:t>
+                      </a:r>
+                      <a:endParaRPr lang="en-US" sz="800" dirty="0">
+                        <a:latin typeface="Calibri" charset="0"/>
+                        <a:ea typeface="Calibri" charset="0"/>
+                        <a:cs typeface="Calibri" charset="0"/>
+                      </a:endParaRPr>
+                    </a:p>
+                  </a:txBody>
+                  <a:tcPr marL="91440" marR="91440" marT="45720" marB="45720" anchor="ctr">
+                    <a:lnL w="0" cap="flat" cmpd="sng" algn="ctr">
+                      <a:noFill/>
+                    </a:lnL>
+                    <a:lnR w="0" cap="flat" cmpd="sng" algn="ctr">
+                      <a:noFill/>
+                    </a:lnR>
+                    <a:lnT w="0" cap="flat" cmpd="sng" algn="ctr">
+                      <a:noFill/>
+                    </a:lnT>
+                    <a:lnB w="0" cap="flat" cmpd="sng" algn="ctr">
+                      <a:noFill/>
+                    </a:lnB>
+                    <a:solidFill>
+                      <a:srgbClr val="FFFFFF"/>
+                    </a:solidFill>
+                  </a:tcPr>
+                </a:tc>
+                <a:tc>
+                  <a:txBody>
+                    <a:bodyPr/>
+                    <a:lstStyle/>
+                    <a:p>
+                      <a:pPr indent="0" marL="0">
+                        <a:buNone/>
+                      </a:pPr>
+                      <a:r>
+                        <a:rPr lang="en-US" sz="800" b="1" dirty="0">
+                          <a:solidFill>
+                            <a:srgbClr val="3A3A3C"/>
+                          </a:solidFill>
+                          <a:latin typeface="Calibri" pitchFamily="34" charset="0"/>
+                          <a:ea typeface="Calibri" pitchFamily="34" charset="-122"/>
+                          <a:cs typeface="Calibri" pitchFamily="34" charset="-120"/>
+                        </a:rPr>
+                        <a:t>NCP Classification &amp; Similar-Case Assistant</a:t>
+                      </a:r>
+                      <a:endParaRPr lang="en-US" sz="800" dirty="0">
+                        <a:latin typeface="Calibri" charset="0"/>
+                        <a:ea typeface="Calibri" charset="0"/>
+                        <a:cs typeface="Calibri" charset="0"/>
+                      </a:endParaRPr>
+                    </a:p>
+                  </a:txBody>
+                  <a:tcPr marL="91440" marR="91440" marT="45720" marB="45720" anchor="ctr">
+                    <a:lnL w="0" cap="flat" cmpd="sng" algn="ctr">
+                      <a:noFill/>
+                    </a:lnL>
+                    <a:lnR w="0" cap="flat" cmpd="sng" algn="ctr">
+                      <a:noFill/>
+                    </a:lnR>
+                    <a:lnT w="0" cap="flat" cmpd="sng" algn="ctr">
+                      <a:noFill/>
+                    </a:lnT>
+                    <a:lnB w="0" cap="flat" cmpd="sng" algn="ctr">
+                      <a:noFill/>
+                    </a:lnB>
+                    <a:solidFill>
+                      <a:srgbClr val="FFFFFF"/>
+                    </a:solidFill>
+                  </a:tcPr>
+                </a:tc>
+                <a:tc>
+                  <a:txBody>
+                    <a:bodyPr/>
+                    <a:lstStyle/>
+                    <a:p>
+                      <a:pPr indent="0" marL="0">
+                        <a:buNone/>
+                      </a:pPr>
+                      <a:r>
+                        <a:rPr lang="en-US" sz="800" dirty="0">
+                          <a:solidFill>
+                            <a:srgbClr val="58595B"/>
+                          </a:solidFill>
+                          <a:latin typeface="Calibri" pitchFamily="34" charset="0"/>
+                          <a:ea typeface="Calibri" pitchFamily="34" charset="-122"/>
+                          <a:cs typeface="Calibri" pitchFamily="34" charset="-120"/>
+                        </a:rPr>
+                        <a:t>Assistive</a:t>
+                      </a:r>
+                      <a:endParaRPr lang="en-US" sz="800" dirty="0">
+                        <a:latin typeface="Calibri" charset="0"/>
+                        <a:ea typeface="Calibri" charset="0"/>
+                        <a:cs typeface="Calibri" charset="0"/>
+                      </a:endParaRPr>
+                    </a:p>
+                  </a:txBody>
+                  <a:tcPr marL="91440" marR="91440" marT="45720" marB="45720" anchor="ctr">
+                    <a:lnL w="0" cap="flat" cmpd="sng" algn="ctr">
+                      <a:noFill/>
+                    </a:lnL>
+                    <a:lnR w="0" cap="flat" cmpd="sng" algn="ctr">
+                      <a:noFill/>
+                    </a:lnR>
+                    <a:lnT w="0" cap="flat" cmpd="sng" algn="ctr">
+                      <a:noFill/>
+                    </a:lnT>
+                    <a:lnB w="0" cap="flat" cmpd="sng" algn="ctr">
+                      <a:noFill/>
+                    </a:lnB>
+                    <a:solidFill>
+                      <a:srgbClr val="FFFFFF"/>
+                    </a:solidFill>
+                  </a:tcPr>
+                </a:tc>
+                <a:tc>
+                  <a:txBody>
+                    <a:bodyPr/>
+                    <a:lstStyle/>
+                    <a:p>
+                      <a:pPr indent="0" marL="0">
+                        <a:buNone/>
+                      </a:pPr>
+                      <a:r>
+                        <a:rPr lang="en-US" sz="800" dirty="0">
+                          <a:solidFill>
+                            <a:srgbClr val="58595B"/>
+                          </a:solidFill>
+                          <a:latin typeface="Calibri" pitchFamily="34" charset="0"/>
+                          <a:ea typeface="Calibri" pitchFamily="34" charset="-122"/>
+                          <a:cs typeface="Calibri" pitchFamily="34" charset="-120"/>
+                        </a:rPr>
+                        <a:t>S1</a:t>
+                      </a:r>
+                      <a:endParaRPr lang="en-US" sz="800" dirty="0">
+                        <a:latin typeface="Calibri" charset="0"/>
+                        <a:ea typeface="Calibri" charset="0"/>
+                        <a:cs typeface="Calibri" charset="0"/>
+                      </a:endParaRPr>
+                    </a:p>
+                  </a:txBody>
+                  <a:tcPr marL="91440" marR="91440" marT="45720" marB="45720" anchor="ctr">
+                    <a:lnL w="0" cap="flat" cmpd="sng" algn="ctr">
+                      <a:noFill/>
+                    </a:lnL>
+                    <a:lnR w="0" cap="flat" cmpd="sng" algn="ctr">
+                      <a:noFill/>
+                    </a:lnR>
+                    <a:lnT w="0" cap="flat" cmpd="sng" algn="ctr">
+                      <a:noFill/>
+                    </a:lnT>
+                    <a:lnB w="0" cap="flat" cmpd="sng" algn="ctr">
+                      <a:noFill/>
+                    </a:lnB>
+                    <a:solidFill>
+                      <a:srgbClr val="FFFFFF"/>
+                    </a:solidFill>
+                  </a:tcPr>
+                </a:tc>
+                <a:tc>
+                  <a:txBody>
+                    <a:bodyPr/>
+                    <a:lstStyle/>
+                    <a:p>
+                      <a:pPr indent="0" marL="0">
+                        <a:buNone/>
+                      </a:pPr>
+                      <a:r>
+                        <a:rPr lang="en-US" sz="800" b="1" dirty="0">
+                          <a:solidFill>
+                            <a:srgbClr val="3A3A3C"/>
+                          </a:solidFill>
+                          <a:latin typeface="Calibri" pitchFamily="34" charset="0"/>
+                          <a:ea typeface="Calibri" pitchFamily="34" charset="-122"/>
+                          <a:cs typeface="Calibri" pitchFamily="34" charset="-120"/>
+                        </a:rPr>
+                        <a:t>Production</a:t>
+                      </a:r>
+                      <a:endParaRPr lang="en-US" sz="800" dirty="0">
+                        <a:latin typeface="Calibri" charset="0"/>
+                        <a:ea typeface="Calibri" charset="0"/>
+                        <a:cs typeface="Calibri" charset="0"/>
+                      </a:endParaRPr>
+                    </a:p>
+                  </a:txBody>
+                  <a:tcPr marL="91440" marR="91440" marT="45720" marB="45720" anchor="ctr">
+                    <a:lnL w="0" cap="flat" cmpd="sng" algn="ctr">
+                      <a:noFill/>
+                    </a:lnL>
+                    <a:lnR w="0" cap="flat" cmpd="sng" algn="ctr">
+                      <a:noFill/>
+                    </a:lnR>
+                    <a:lnT w="0" cap="flat" cmpd="sng" algn="ctr">
+                      <a:noFill/>
+                    </a:lnT>
+                    <a:lnB w="0" cap="flat" cmpd="sng" algn="ctr">
+                      <a:noFill/>
+                    </a:lnB>
+                    <a:solidFill>
+                      <a:srgbClr val="FFFFFF"/>
+                    </a:solidFill>
+                  </a:tcPr>
+                </a:tc>
+                <a:tc>
+                  <a:txBody>
+                    <a:bodyPr/>
+                    <a:lstStyle/>
+                    <a:p>
+                      <a:pPr indent="0" marL="0">
+                        <a:buNone/>
+                      </a:pPr>
+                      <a:r>
+                        <a:rPr lang="en-US" sz="800" dirty="0">
+                          <a:solidFill>
+                            <a:srgbClr val="58595B"/>
+                          </a:solidFill>
+                          <a:latin typeface="Calibri" pitchFamily="34" charset="0"/>
+                          <a:ea typeface="Calibri" pitchFamily="34" charset="-122"/>
+                          <a:cs typeface="Calibri" pitchFamily="34" charset="-120"/>
+                        </a:rPr>
+                        <a:t>Suggests initial criticality, priority, and similar past Sheets when a new problem is registered.</a:t>
+                      </a:r>
+                      <a:endParaRPr lang="en-US" sz="800" dirty="0">
+                        <a:latin typeface="Calibri" charset="0"/>
+                        <a:ea typeface="Calibri" charset="0"/>
+                        <a:cs typeface="Calibri" charset="0"/>
+                      </a:endParaRPr>
+                    </a:p>
+                  </a:txBody>
+                  <a:tcPr marL="91440" marR="91440" marT="45720" marB="45720" anchor="ctr">
+                    <a:lnL w="0" cap="flat" cmpd="sng" algn="ctr">
+                      <a:noFill/>
+                    </a:lnL>
+                    <a:lnR w="0" cap="flat" cmpd="sng" algn="ctr">
+                      <a:noFill/>
+                    </a:lnR>
+                    <a:lnT w="0" cap="flat" cmpd="sng" algn="ctr">
+                      <a:noFill/>
+                    </a:lnT>
+                    <a:lnB w="0" cap="flat" cmpd="sng" algn="ctr">
+                      <a:noFill/>
+                    </a:lnB>
+                    <a:solidFill>
+                      <a:srgbClr val="FFFFFF"/>
+                    </a:solidFill>
+                  </a:tcPr>
+                </a:tc>
+              </a:tr>
+              <a:tr h="290779">
+                <a:tc>
+                  <a:txBody>
+                    <a:bodyPr/>
+                    <a:lstStyle/>
+                    <a:p>
+                      <a:pPr algn="ctr" indent="0" marL="0">
+                        <a:buNone/>
+                      </a:pPr>
+                      <a:r>
+                        <a:rPr lang="en-US" sz="800" dirty="0">
+                          <a:solidFill>
+                            <a:srgbClr val="808184"/>
+                          </a:solidFill>
+                          <a:latin typeface="Calibri" pitchFamily="34" charset="0"/>
+                          <a:ea typeface="Calibri" pitchFamily="34" charset="-122"/>
+                          <a:cs typeface="Calibri" pitchFamily="34" charset="-120"/>
+                        </a:rPr>
+                        <a:t>2</a:t>
+                      </a:r>
+                      <a:endParaRPr lang="en-US" sz="800" dirty="0">
+                        <a:latin typeface="Calibri" charset="0"/>
+                        <a:ea typeface="Calibri" charset="0"/>
+                        <a:cs typeface="Calibri" charset="0"/>
+                      </a:endParaRPr>
+                    </a:p>
+                  </a:txBody>
+                  <a:tcPr marL="91440" marR="91440" marT="45720" marB="45720" anchor="ctr">
+                    <a:lnL w="0" cap="flat" cmpd="sng" algn="ctr">
+                      <a:noFill/>
+                    </a:lnL>
+                    <a:lnR w="0" cap="flat" cmpd="sng" algn="ctr">
+                      <a:noFill/>
+                    </a:lnR>
+                    <a:lnT w="0" cap="flat" cmpd="sng" algn="ctr">
+                      <a:noFill/>
+                    </a:lnT>
+                    <a:lnB w="0" cap="flat" cmpd="sng" algn="ctr">
+                      <a:noFill/>
+                    </a:lnB>
+                    <a:solidFill>
+                      <a:srgbClr val="F2F2F3"/>
+                    </a:solidFill>
+                  </a:tcPr>
+                </a:tc>
+                <a:tc>
+                  <a:txBody>
+                    <a:bodyPr/>
+                    <a:lstStyle/>
+                    <a:p>
+                      <a:pPr indent="0" marL="0">
+                        <a:buNone/>
+                      </a:pPr>
+                      <a:r>
+                        <a:rPr lang="en-US" sz="800" b="1" dirty="0">
+                          <a:solidFill>
+                            <a:srgbClr val="3A3A3C"/>
+                          </a:solidFill>
+                          <a:latin typeface="Calibri" pitchFamily="34" charset="0"/>
+                          <a:ea typeface="Calibri" pitchFamily="34" charset="-122"/>
+                          <a:cs typeface="Calibri" pitchFamily="34" charset="-120"/>
+                        </a:rPr>
+                        <a:t>5W2H Problem-Structuring Assistant</a:t>
+                      </a:r>
+                      <a:endParaRPr lang="en-US" sz="800" dirty="0">
+                        <a:latin typeface="Calibri" charset="0"/>
+                        <a:ea typeface="Calibri" charset="0"/>
+                        <a:cs typeface="Calibri" charset="0"/>
+                      </a:endParaRPr>
+                    </a:p>
+                  </a:txBody>
+                  <a:tcPr marL="91440" marR="91440" marT="45720" marB="45720" anchor="ctr">
+                    <a:lnL w="0" cap="flat" cmpd="sng" algn="ctr">
+                      <a:noFill/>
+                    </a:lnL>
+                    <a:lnR w="0" cap="flat" cmpd="sng" algn="ctr">
+                      <a:noFill/>
+                    </a:lnR>
+                    <a:lnT w="0" cap="flat" cmpd="sng" algn="ctr">
+                      <a:noFill/>
+                    </a:lnT>
+                    <a:lnB w="0" cap="flat" cmpd="sng" algn="ctr">
+                      <a:noFill/>
+                    </a:lnB>
+                    <a:solidFill>
+                      <a:srgbClr val="F2F2F3"/>
+                    </a:solidFill>
+                  </a:tcPr>
+                </a:tc>
+                <a:tc>
+                  <a:txBody>
+                    <a:bodyPr/>
+                    <a:lstStyle/>
+                    <a:p>
+                      <a:pPr indent="0" marL="0">
+                        <a:buNone/>
+                      </a:pPr>
+                      <a:r>
+                        <a:rPr lang="en-US" sz="800" b="1" dirty="0">
+                          <a:solidFill>
+                            <a:srgbClr val="E07B00"/>
+                          </a:solidFill>
+                          <a:latin typeface="Calibri" pitchFamily="34" charset="0"/>
+                          <a:ea typeface="Calibri" pitchFamily="34" charset="-122"/>
+                          <a:cs typeface="Calibri" pitchFamily="34" charset="-120"/>
+                        </a:rPr>
+                        <a:t>Augmented</a:t>
+                      </a:r>
+                      <a:endParaRPr lang="en-US" sz="800" dirty="0">
+                        <a:latin typeface="Calibri" charset="0"/>
+                        <a:ea typeface="Calibri" charset="0"/>
+                        <a:cs typeface="Calibri" charset="0"/>
+                      </a:endParaRPr>
+                    </a:p>
+                  </a:txBody>
+                  <a:tcPr marL="91440" marR="91440" marT="45720" marB="45720" anchor="ctr">
+                    <a:lnL w="0" cap="flat" cmpd="sng" algn="ctr">
+                      <a:noFill/>
+                    </a:lnL>
+                    <a:lnR w="0" cap="flat" cmpd="sng" algn="ctr">
+                      <a:noFill/>
+                    </a:lnR>
+                    <a:lnT w="0" cap="flat" cmpd="sng" algn="ctr">
+                      <a:noFill/>
+                    </a:lnT>
+                    <a:lnB w="0" cap="flat" cmpd="sng" algn="ctr">
+                      <a:noFill/>
+                    </a:lnB>
+                    <a:solidFill>
+                      <a:srgbClr val="F2F2F3"/>
+                    </a:solidFill>
+                  </a:tcPr>
+                </a:tc>
+                <a:tc>
+                  <a:txBody>
+                    <a:bodyPr/>
+                    <a:lstStyle/>
+                    <a:p>
+                      <a:pPr indent="0" marL="0">
+                        <a:buNone/>
+                      </a:pPr>
+                      <a:r>
+                        <a:rPr lang="en-US" sz="800" dirty="0">
+                          <a:solidFill>
+                            <a:srgbClr val="58595B"/>
+                          </a:solidFill>
+                          <a:latin typeface="Calibri" pitchFamily="34" charset="0"/>
+                          <a:ea typeface="Calibri" pitchFamily="34" charset="-122"/>
+                          <a:cs typeface="Calibri" pitchFamily="34" charset="-120"/>
+                        </a:rPr>
+                        <a:t>S2</a:t>
+                      </a:r>
+                      <a:endParaRPr lang="en-US" sz="800" dirty="0">
+                        <a:latin typeface="Calibri" charset="0"/>
+                        <a:ea typeface="Calibri" charset="0"/>
+                        <a:cs typeface="Calibri" charset="0"/>
+                      </a:endParaRPr>
+                    </a:p>
+                  </a:txBody>
+                  <a:tcPr marL="91440" marR="91440" marT="45720" marB="45720" anchor="ctr">
+                    <a:lnL w="0" cap="flat" cmpd="sng" algn="ctr">
+                      <a:noFill/>
+                    </a:lnL>
+                    <a:lnR w="0" cap="flat" cmpd="sng" algn="ctr">
+                      <a:noFill/>
+                    </a:lnR>
+                    <a:lnT w="0" cap="flat" cmpd="sng" algn="ctr">
+                      <a:noFill/>
+                    </a:lnT>
+                    <a:lnB w="0" cap="flat" cmpd="sng" algn="ctr">
+                      <a:noFill/>
+                    </a:lnB>
+                    <a:solidFill>
+                      <a:srgbClr val="F2F2F3"/>
+                    </a:solidFill>
+                  </a:tcPr>
+                </a:tc>
+                <a:tc>
+                  <a:txBody>
+                    <a:bodyPr/>
+                    <a:lstStyle/>
+                    <a:p>
+                      <a:pPr indent="0" marL="0">
+                        <a:buNone/>
+                      </a:pPr>
+                      <a:r>
+                        <a:rPr lang="en-US" sz="800" b="1" dirty="0">
+                          <a:solidFill>
+                            <a:srgbClr val="3A3A3C"/>
+                          </a:solidFill>
+                          <a:latin typeface="Calibri" pitchFamily="34" charset="0"/>
+                          <a:ea typeface="Calibri" pitchFamily="34" charset="-122"/>
+                          <a:cs typeface="Calibri" pitchFamily="34" charset="-120"/>
+                        </a:rPr>
+                        <a:t>Production</a:t>
+                      </a:r>
+                      <a:endParaRPr lang="en-US" sz="800" dirty="0">
+                        <a:latin typeface="Calibri" charset="0"/>
+                        <a:ea typeface="Calibri" charset="0"/>
+                        <a:cs typeface="Calibri" charset="0"/>
+                      </a:endParaRPr>
+                    </a:p>
+                  </a:txBody>
+                  <a:tcPr marL="91440" marR="91440" marT="45720" marB="45720" anchor="ctr">
+                    <a:lnL w="0" cap="flat" cmpd="sng" algn="ctr">
+                      <a:noFill/>
+                    </a:lnL>
+                    <a:lnR w="0" cap="flat" cmpd="sng" algn="ctr">
+                      <a:noFill/>
+                    </a:lnR>
+                    <a:lnT w="0" cap="flat" cmpd="sng" algn="ctr">
+                      <a:noFill/>
+                    </a:lnT>
+                    <a:lnB w="0" cap="flat" cmpd="sng" algn="ctr">
+                      <a:noFill/>
+                    </a:lnB>
+                    <a:solidFill>
+                      <a:srgbClr val="F2F2F3"/>
+                    </a:solidFill>
+                  </a:tcPr>
+                </a:tc>
+                <a:tc>
+                  <a:txBody>
+                    <a:bodyPr/>
+                    <a:lstStyle/>
+                    <a:p>
+                      <a:pPr indent="0" marL="0">
+                        <a:buNone/>
+                      </a:pPr>
+                      <a:r>
+                        <a:rPr lang="en-US" sz="800" dirty="0">
+                          <a:solidFill>
+                            <a:srgbClr val="58595B"/>
+                          </a:solidFill>
+                          <a:latin typeface="Calibri" pitchFamily="34" charset="0"/>
+                          <a:ea typeface="Calibri" pitchFamily="34" charset="-122"/>
+                          <a:cs typeface="Calibri" pitchFamily="34" charset="-120"/>
+                        </a:rPr>
+                        <a:t>Drafts a starting 5W2H breakdown from the Sheet's title and description for the team to refine.</a:t>
+                      </a:r>
+                      <a:endParaRPr lang="en-US" sz="800" dirty="0">
+                        <a:latin typeface="Calibri" charset="0"/>
+                        <a:ea typeface="Calibri" charset="0"/>
+                        <a:cs typeface="Calibri" charset="0"/>
+                      </a:endParaRPr>
+                    </a:p>
+                  </a:txBody>
+                  <a:tcPr marL="91440" marR="91440" marT="45720" marB="45720" anchor="ctr">
+                    <a:lnL w="0" cap="flat" cmpd="sng" algn="ctr">
+                      <a:noFill/>
+                    </a:lnL>
+                    <a:lnR w="0" cap="flat" cmpd="sng" algn="ctr">
+                      <a:noFill/>
+                    </a:lnR>
+                    <a:lnT w="0" cap="flat" cmpd="sng" algn="ctr">
+                      <a:noFill/>
+                    </a:lnT>
+                    <a:lnB w="0" cap="flat" cmpd="sng" algn="ctr">
+                      <a:noFill/>
+                    </a:lnB>
+                    <a:solidFill>
+                      <a:srgbClr val="F2F2F3"/>
+                    </a:solidFill>
+                  </a:tcPr>
+                </a:tc>
+              </a:tr>
+              <a:tr h="290779">
+                <a:tc>
+                  <a:txBody>
+                    <a:bodyPr/>
+                    <a:lstStyle/>
+                    <a:p>
+                      <a:pPr algn="ctr" indent="0" marL="0">
+                        <a:buNone/>
+                      </a:pPr>
+                      <a:r>
+                        <a:rPr lang="en-US" sz="800" dirty="0">
+                          <a:solidFill>
+                            <a:srgbClr val="808184"/>
+                          </a:solidFill>
+                          <a:latin typeface="Calibri" pitchFamily="34" charset="0"/>
+                          <a:ea typeface="Calibri" pitchFamily="34" charset="-122"/>
+                          <a:cs typeface="Calibri" pitchFamily="34" charset="-120"/>
+                        </a:rPr>
+                        <a:t>3</a:t>
+                      </a:r>
+                      <a:endParaRPr lang="en-US" sz="800" dirty="0">
+                        <a:latin typeface="Calibri" charset="0"/>
+                        <a:ea typeface="Calibri" charset="0"/>
+                        <a:cs typeface="Calibri" charset="0"/>
+                      </a:endParaRPr>
+                    </a:p>
+                  </a:txBody>
+                  <a:tcPr marL="91440" marR="91440" marT="45720" marB="45720" anchor="ctr">
+                    <a:lnL w="0" cap="flat" cmpd="sng" algn="ctr">
+                      <a:noFill/>
+                    </a:lnL>
+                    <a:lnR w="0" cap="flat" cmpd="sng" algn="ctr">
+                      <a:noFill/>
+                    </a:lnR>
+                    <a:lnT w="0" cap="flat" cmpd="sng" algn="ctr">
+                      <a:noFill/>
+                    </a:lnT>
+                    <a:lnB w="0" cap="flat" cmpd="sng" algn="ctr">
+                      <a:noFill/>
+                    </a:lnB>
+                    <a:solidFill>
+                      <a:srgbClr val="FFFFFF"/>
+                    </a:solidFill>
+                  </a:tcPr>
+                </a:tc>
+                <a:tc>
+                  <a:txBody>
+                    <a:bodyPr/>
+                    <a:lstStyle/>
+                    <a:p>
+                      <a:pPr indent="0" marL="0">
+                        <a:buNone/>
+                      </a:pPr>
+                      <a:r>
+                        <a:rPr lang="en-US" sz="800" b="1" dirty="0">
+                          <a:solidFill>
+                            <a:srgbClr val="3A3A3C"/>
+                          </a:solidFill>
+                          <a:latin typeface="Calibri" pitchFamily="34" charset="0"/>
+                          <a:ea typeface="Calibri" pitchFamily="34" charset="-122"/>
+                          <a:cs typeface="Calibri" pitchFamily="34" charset="-120"/>
+                        </a:rPr>
+                        <a:t>Immediate Containment Action Advisor</a:t>
+                      </a:r>
+                      <a:endParaRPr lang="en-US" sz="800" dirty="0">
+                        <a:latin typeface="Calibri" charset="0"/>
+                        <a:ea typeface="Calibri" charset="0"/>
+                        <a:cs typeface="Calibri" charset="0"/>
+                      </a:endParaRPr>
+                    </a:p>
+                  </a:txBody>
+                  <a:tcPr marL="91440" marR="91440" marT="45720" marB="45720" anchor="ctr">
+                    <a:lnL w="0" cap="flat" cmpd="sng" algn="ctr">
+                      <a:noFill/>
+                    </a:lnL>
+                    <a:lnR w="0" cap="flat" cmpd="sng" algn="ctr">
+                      <a:noFill/>
+                    </a:lnR>
+                    <a:lnT w="0" cap="flat" cmpd="sng" algn="ctr">
+                      <a:noFill/>
+                    </a:lnT>
+                    <a:lnB w="0" cap="flat" cmpd="sng" algn="ctr">
+                      <a:noFill/>
+                    </a:lnB>
+                    <a:solidFill>
+                      <a:srgbClr val="FFFFFF"/>
+                    </a:solidFill>
+                  </a:tcPr>
+                </a:tc>
+                <a:tc>
+                  <a:txBody>
+                    <a:bodyPr/>
+                    <a:lstStyle/>
+                    <a:p>
+                      <a:pPr indent="0" marL="0">
+                        <a:buNone/>
+                      </a:pPr>
+                      <a:r>
+                        <a:rPr lang="en-US" sz="800" dirty="0">
+                          <a:solidFill>
+                            <a:srgbClr val="58595B"/>
+                          </a:solidFill>
+                          <a:latin typeface="Calibri" pitchFamily="34" charset="0"/>
+                          <a:ea typeface="Calibri" pitchFamily="34" charset="-122"/>
+                          <a:cs typeface="Calibri" pitchFamily="34" charset="-120"/>
+                        </a:rPr>
+                        <a:t>Assistive</a:t>
+                      </a:r>
+                      <a:endParaRPr lang="en-US" sz="800" dirty="0">
+                        <a:latin typeface="Calibri" charset="0"/>
+                        <a:ea typeface="Calibri" charset="0"/>
+                        <a:cs typeface="Calibri" charset="0"/>
+                      </a:endParaRPr>
+                    </a:p>
+                  </a:txBody>
+                  <a:tcPr marL="91440" marR="91440" marT="45720" marB="45720" anchor="ctr">
+                    <a:lnL w="0" cap="flat" cmpd="sng" algn="ctr">
+                      <a:noFill/>
+                    </a:lnL>
+                    <a:lnR w="0" cap="flat" cmpd="sng" algn="ctr">
+                      <a:noFill/>
+                    </a:lnR>
+                    <a:lnT w="0" cap="flat" cmpd="sng" algn="ctr">
+                      <a:noFill/>
+                    </a:lnT>
+                    <a:lnB w="0" cap="flat" cmpd="sng" algn="ctr">
+                      <a:noFill/>
+                    </a:lnB>
+                    <a:solidFill>
+                      <a:srgbClr val="FFFFFF"/>
+                    </a:solidFill>
+                  </a:tcPr>
+                </a:tc>
+                <a:tc>
+                  <a:txBody>
+                    <a:bodyPr/>
+                    <a:lstStyle/>
+                    <a:p>
+                      <a:pPr indent="0" marL="0">
+                        <a:buNone/>
+                      </a:pPr>
+                      <a:r>
+                        <a:rPr lang="en-US" sz="800" dirty="0">
+                          <a:solidFill>
+                            <a:srgbClr val="58595B"/>
+                          </a:solidFill>
+                          <a:latin typeface="Calibri" pitchFamily="34" charset="0"/>
+                          <a:ea typeface="Calibri" pitchFamily="34" charset="-122"/>
+                          <a:cs typeface="Calibri" pitchFamily="34" charset="-120"/>
+                        </a:rPr>
+                        <a:t>S3</a:t>
+                      </a:r>
+                      <a:endParaRPr lang="en-US" sz="800" dirty="0">
+                        <a:latin typeface="Calibri" charset="0"/>
+                        <a:ea typeface="Calibri" charset="0"/>
+                        <a:cs typeface="Calibri" charset="0"/>
+                      </a:endParaRPr>
+                    </a:p>
+                  </a:txBody>
+                  <a:tcPr marL="91440" marR="91440" marT="45720" marB="45720" anchor="ctr">
+                    <a:lnL w="0" cap="flat" cmpd="sng" algn="ctr">
+                      <a:noFill/>
+                    </a:lnL>
+                    <a:lnR w="0" cap="flat" cmpd="sng" algn="ctr">
+                      <a:noFill/>
+                    </a:lnR>
+                    <a:lnT w="0" cap="flat" cmpd="sng" algn="ctr">
+                      <a:noFill/>
+                    </a:lnT>
+                    <a:lnB w="0" cap="flat" cmpd="sng" algn="ctr">
+                      <a:noFill/>
+                    </a:lnB>
+                    <a:solidFill>
+                      <a:srgbClr val="FFFFFF"/>
+                    </a:solidFill>
+                  </a:tcPr>
+                </a:tc>
+                <a:tc>
+                  <a:txBody>
+                    <a:bodyPr/>
+                    <a:lstStyle/>
+                    <a:p>
+                      <a:pPr indent="0" marL="0">
+                        <a:buNone/>
+                      </a:pPr>
+                      <a:r>
+                        <a:rPr lang="en-US" sz="800" b="1" dirty="0">
+                          <a:solidFill>
+                            <a:srgbClr val="3A3A3C"/>
+                          </a:solidFill>
+                          <a:latin typeface="Calibri" pitchFamily="34" charset="0"/>
+                          <a:ea typeface="Calibri" pitchFamily="34" charset="-122"/>
+                          <a:cs typeface="Calibri" pitchFamily="34" charset="-120"/>
+                        </a:rPr>
+                        <a:t>Production</a:t>
+                      </a:r>
+                      <a:endParaRPr lang="en-US" sz="800" dirty="0">
+                        <a:latin typeface="Calibri" charset="0"/>
+                        <a:ea typeface="Calibri" charset="0"/>
+                        <a:cs typeface="Calibri" charset="0"/>
+                      </a:endParaRPr>
+                    </a:p>
+                  </a:txBody>
+                  <a:tcPr marL="91440" marR="91440" marT="45720" marB="45720" anchor="ctr">
+                    <a:lnL w="0" cap="flat" cmpd="sng" algn="ctr">
+                      <a:noFill/>
+                    </a:lnL>
+                    <a:lnR w="0" cap="flat" cmpd="sng" algn="ctr">
+                      <a:noFill/>
+                    </a:lnR>
+                    <a:lnT w="0" cap="flat" cmpd="sng" algn="ctr">
+                      <a:noFill/>
+                    </a:lnT>
+                    <a:lnB w="0" cap="flat" cmpd="sng" algn="ctr">
+                      <a:noFill/>
+                    </a:lnB>
+                    <a:solidFill>
+                      <a:srgbClr val="FFFFFF"/>
+                    </a:solidFill>
+                  </a:tcPr>
+                </a:tc>
+                <a:tc>
+                  <a:txBody>
+                    <a:bodyPr/>
+                    <a:lstStyle/>
+                    <a:p>
+                      <a:pPr indent="0" marL="0">
+                        <a:buNone/>
+                      </a:pPr>
+                      <a:r>
+                        <a:rPr lang="en-US" sz="800" dirty="0">
+                          <a:solidFill>
+                            <a:srgbClr val="58595B"/>
+                          </a:solidFill>
+                          <a:latin typeface="Calibri" pitchFamily="34" charset="0"/>
+                          <a:ea typeface="Calibri" pitchFamily="34" charset="-122"/>
+                          <a:cs typeface="Calibri" pitchFamily="34" charset="-120"/>
+                        </a:rPr>
+                        <a:t>Retrieves containment actions that worked on similar past problems in the organization.</a:t>
+                      </a:r>
+                      <a:endParaRPr lang="en-US" sz="800" dirty="0">
+                        <a:latin typeface="Calibri" charset="0"/>
+                        <a:ea typeface="Calibri" charset="0"/>
+                        <a:cs typeface="Calibri" charset="0"/>
+                      </a:endParaRPr>
+                    </a:p>
+                  </a:txBody>
+                  <a:tcPr marL="91440" marR="91440" marT="45720" marB="45720" anchor="ctr">
+                    <a:lnL w="0" cap="flat" cmpd="sng" algn="ctr">
+                      <a:noFill/>
+                    </a:lnL>
+                    <a:lnR w="0" cap="flat" cmpd="sng" algn="ctr">
+                      <a:noFill/>
+                    </a:lnR>
+                    <a:lnT w="0" cap="flat" cmpd="sng" algn="ctr">
+                      <a:noFill/>
+                    </a:lnT>
+                    <a:lnB w="0" cap="flat" cmpd="sng" algn="ctr">
+                      <a:noFill/>
+                    </a:lnB>
+                    <a:solidFill>
+                      <a:srgbClr val="FFFFFF"/>
+                    </a:solidFill>
+                  </a:tcPr>
+                </a:tc>
+              </a:tr>
+              <a:tr h="290779">
+                <a:tc>
+                  <a:txBody>
+                    <a:bodyPr/>
+                    <a:lstStyle/>
+                    <a:p>
+                      <a:pPr algn="ctr" indent="0" marL="0">
+                        <a:buNone/>
+                      </a:pPr>
+                      <a:r>
+                        <a:rPr lang="en-US" sz="800" dirty="0">
+                          <a:solidFill>
+                            <a:srgbClr val="808184"/>
+                          </a:solidFill>
+                          <a:latin typeface="Calibri" pitchFamily="34" charset="0"/>
+                          <a:ea typeface="Calibri" pitchFamily="34" charset="-122"/>
+                          <a:cs typeface="Calibri" pitchFamily="34" charset="-120"/>
+                        </a:rPr>
+                        <a:t>4</a:t>
+                      </a:r>
+                      <a:endParaRPr lang="en-US" sz="800" dirty="0">
+                        <a:latin typeface="Calibri" charset="0"/>
+                        <a:ea typeface="Calibri" charset="0"/>
+                        <a:cs typeface="Calibri" charset="0"/>
+                      </a:endParaRPr>
+                    </a:p>
+                  </a:txBody>
+                  <a:tcPr marL="91440" marR="91440" marT="45720" marB="45720" anchor="ctr">
+                    <a:lnL w="0" cap="flat" cmpd="sng" algn="ctr">
+                      <a:noFill/>
+                    </a:lnL>
+                    <a:lnR w="0" cap="flat" cmpd="sng" algn="ctr">
+                      <a:noFill/>
+                    </a:lnR>
+                    <a:lnT w="0" cap="flat" cmpd="sng" algn="ctr">
+                      <a:noFill/>
+                    </a:lnT>
+                    <a:lnB w="0" cap="flat" cmpd="sng" algn="ctr">
+                      <a:noFill/>
+                    </a:lnB>
+                    <a:solidFill>
+                      <a:srgbClr val="F2F2F3"/>
+                    </a:solidFill>
+                  </a:tcPr>
+                </a:tc>
+                <a:tc>
+                  <a:txBody>
+                    <a:bodyPr/>
+                    <a:lstStyle/>
+                    <a:p>
+                      <a:pPr indent="0" marL="0">
+                        <a:buNone/>
+                      </a:pPr>
+                      <a:r>
+                        <a:rPr lang="en-US" sz="800" b="1" dirty="0">
+                          <a:solidFill>
+                            <a:srgbClr val="3A3A3C"/>
+                          </a:solidFill>
+                          <a:latin typeface="Calibri" pitchFamily="34" charset="0"/>
+                          <a:ea typeface="Calibri" pitchFamily="34" charset="-122"/>
+                          <a:cs typeface="Calibri" pitchFamily="34" charset="-120"/>
+                        </a:rPr>
+                        <a:t>Root Cause Mining Assistant</a:t>
+                      </a:r>
+                      <a:endParaRPr lang="en-US" sz="800" dirty="0">
+                        <a:latin typeface="Calibri" charset="0"/>
+                        <a:ea typeface="Calibri" charset="0"/>
+                        <a:cs typeface="Calibri" charset="0"/>
+                      </a:endParaRPr>
+                    </a:p>
+                  </a:txBody>
+                  <a:tcPr marL="91440" marR="91440" marT="45720" marB="45720" anchor="ctr">
+                    <a:lnL w="0" cap="flat" cmpd="sng" algn="ctr">
+                      <a:noFill/>
+                    </a:lnL>
+                    <a:lnR w="0" cap="flat" cmpd="sng" algn="ctr">
+                      <a:noFill/>
+                    </a:lnR>
+                    <a:lnT w="0" cap="flat" cmpd="sng" algn="ctr">
+                      <a:noFill/>
+                    </a:lnT>
+                    <a:lnB w="0" cap="flat" cmpd="sng" algn="ctr">
+                      <a:noFill/>
+                    </a:lnB>
+                    <a:solidFill>
+                      <a:srgbClr val="F2F2F3"/>
+                    </a:solidFill>
+                  </a:tcPr>
+                </a:tc>
+                <a:tc>
+                  <a:txBody>
+                    <a:bodyPr/>
+                    <a:lstStyle/>
+                    <a:p>
+                      <a:pPr indent="0" marL="0">
+                        <a:buNone/>
+                      </a:pPr>
+                      <a:r>
+                        <a:rPr lang="en-US" sz="800" dirty="0">
+                          <a:solidFill>
+                            <a:srgbClr val="58595B"/>
+                          </a:solidFill>
+                          <a:latin typeface="Calibri" pitchFamily="34" charset="0"/>
+                          <a:ea typeface="Calibri" pitchFamily="34" charset="-122"/>
+                          <a:cs typeface="Calibri" pitchFamily="34" charset="-120"/>
+                        </a:rPr>
+                        <a:t>Assistive</a:t>
+                      </a:r>
+                      <a:endParaRPr lang="en-US" sz="800" dirty="0">
+                        <a:latin typeface="Calibri" charset="0"/>
+                        <a:ea typeface="Calibri" charset="0"/>
+                        <a:cs typeface="Calibri" charset="0"/>
+                      </a:endParaRPr>
+                    </a:p>
+                  </a:txBody>
+                  <a:tcPr marL="91440" marR="91440" marT="45720" marB="45720" anchor="ctr">
+                    <a:lnL w="0" cap="flat" cmpd="sng" algn="ctr">
+                      <a:noFill/>
+                    </a:lnL>
+                    <a:lnR w="0" cap="flat" cmpd="sng" algn="ctr">
+                      <a:noFill/>
+                    </a:lnR>
+                    <a:lnT w="0" cap="flat" cmpd="sng" algn="ctr">
+                      <a:noFill/>
+                    </a:lnT>
+                    <a:lnB w="0" cap="flat" cmpd="sng" algn="ctr">
+                      <a:noFill/>
+                    </a:lnB>
+                    <a:solidFill>
+                      <a:srgbClr val="F2F2F3"/>
+                    </a:solidFill>
+                  </a:tcPr>
+                </a:tc>
+                <a:tc>
+                  <a:txBody>
+                    <a:bodyPr/>
+                    <a:lstStyle/>
+                    <a:p>
+                      <a:pPr indent="0" marL="0">
+                        <a:buNone/>
+                      </a:pPr>
+                      <a:r>
+                        <a:rPr lang="en-US" sz="800" dirty="0">
+                          <a:solidFill>
+                            <a:srgbClr val="58595B"/>
+                          </a:solidFill>
+                          <a:latin typeface="Calibri" pitchFamily="34" charset="0"/>
+                          <a:ea typeface="Calibri" pitchFamily="34" charset="-122"/>
+                          <a:cs typeface="Calibri" pitchFamily="34" charset="-120"/>
+                        </a:rPr>
+                        <a:t>S4</a:t>
+                      </a:r>
+                      <a:endParaRPr lang="en-US" sz="800" dirty="0">
+                        <a:latin typeface="Calibri" charset="0"/>
+                        <a:ea typeface="Calibri" charset="0"/>
+                        <a:cs typeface="Calibri" charset="0"/>
+                      </a:endParaRPr>
+                    </a:p>
+                  </a:txBody>
+                  <a:tcPr marL="91440" marR="91440" marT="45720" marB="45720" anchor="ctr">
+                    <a:lnL w="0" cap="flat" cmpd="sng" algn="ctr">
+                      <a:noFill/>
+                    </a:lnL>
+                    <a:lnR w="0" cap="flat" cmpd="sng" algn="ctr">
+                      <a:noFill/>
+                    </a:lnR>
+                    <a:lnT w="0" cap="flat" cmpd="sng" algn="ctr">
+                      <a:noFill/>
+                    </a:lnT>
+                    <a:lnB w="0" cap="flat" cmpd="sng" algn="ctr">
+                      <a:noFill/>
+                    </a:lnB>
+                    <a:solidFill>
+                      <a:srgbClr val="F2F2F3"/>
+                    </a:solidFill>
+                  </a:tcPr>
+                </a:tc>
+                <a:tc>
+                  <a:txBody>
+                    <a:bodyPr/>
+                    <a:lstStyle/>
+                    <a:p>
+                      <a:pPr indent="0" marL="0">
+                        <a:buNone/>
+                      </a:pPr>
+                      <a:r>
+                        <a:rPr lang="en-US" sz="800" b="1" dirty="0">
+                          <a:solidFill>
+                            <a:srgbClr val="3A3A3C"/>
+                          </a:solidFill>
+                          <a:latin typeface="Calibri" pitchFamily="34" charset="0"/>
+                          <a:ea typeface="Calibri" pitchFamily="34" charset="-122"/>
+                          <a:cs typeface="Calibri" pitchFamily="34" charset="-120"/>
+                        </a:rPr>
+                        <a:t>Production</a:t>
+                      </a:r>
+                      <a:endParaRPr lang="en-US" sz="800" dirty="0">
+                        <a:latin typeface="Calibri" charset="0"/>
+                        <a:ea typeface="Calibri" charset="0"/>
+                        <a:cs typeface="Calibri" charset="0"/>
+                      </a:endParaRPr>
+                    </a:p>
+                  </a:txBody>
+                  <a:tcPr marL="91440" marR="91440" marT="45720" marB="45720" anchor="ctr">
+                    <a:lnL w="0" cap="flat" cmpd="sng" algn="ctr">
+                      <a:noFill/>
+                    </a:lnL>
+                    <a:lnR w="0" cap="flat" cmpd="sng" algn="ctr">
+                      <a:noFill/>
+                    </a:lnR>
+                    <a:lnT w="0" cap="flat" cmpd="sng" algn="ctr">
+                      <a:noFill/>
+                    </a:lnT>
+                    <a:lnB w="0" cap="flat" cmpd="sng" algn="ctr">
+                      <a:noFill/>
+                    </a:lnB>
+                    <a:solidFill>
+                      <a:srgbClr val="F2F2F3"/>
+                    </a:solidFill>
+                  </a:tcPr>
+                </a:tc>
+                <a:tc>
+                  <a:txBody>
+                    <a:bodyPr/>
+                    <a:lstStyle/>
+                    <a:p>
+                      <a:pPr indent="0" marL="0">
+                        <a:buNone/>
+                      </a:pPr>
+                      <a:r>
+                        <a:rPr lang="en-US" sz="800" dirty="0">
+                          <a:solidFill>
+                            <a:srgbClr val="58595B"/>
+                          </a:solidFill>
+                          <a:latin typeface="Calibri" pitchFamily="34" charset="0"/>
+                          <a:ea typeface="Calibri" pitchFamily="34" charset="-122"/>
+                          <a:cs typeface="Calibri" pitchFamily="34" charset="-120"/>
+                        </a:rPr>
+                        <a:t>Mines closed Sheets for candidate root causes and 6M categories like the current problem.</a:t>
+                      </a:r>
+                      <a:endParaRPr lang="en-US" sz="800" dirty="0">
+                        <a:latin typeface="Calibri" charset="0"/>
+                        <a:ea typeface="Calibri" charset="0"/>
+                        <a:cs typeface="Calibri" charset="0"/>
+                      </a:endParaRPr>
+                    </a:p>
+                  </a:txBody>
+                  <a:tcPr marL="91440" marR="91440" marT="45720" marB="45720" anchor="ctr">
+                    <a:lnL w="0" cap="flat" cmpd="sng" algn="ctr">
+                      <a:noFill/>
+                    </a:lnL>
+                    <a:lnR w="0" cap="flat" cmpd="sng" algn="ctr">
+                      <a:noFill/>
+                    </a:lnR>
+                    <a:lnT w="0" cap="flat" cmpd="sng" algn="ctr">
+                      <a:noFill/>
+                    </a:lnT>
+                    <a:lnB w="0" cap="flat" cmpd="sng" algn="ctr">
+                      <a:noFill/>
+                    </a:lnB>
+                    <a:solidFill>
+                      <a:srgbClr val="F2F2F3"/>
+                    </a:solidFill>
+                  </a:tcPr>
+                </a:tc>
+              </a:tr>
+              <a:tr h="290779">
+                <a:tc>
+                  <a:txBody>
+                    <a:bodyPr/>
+                    <a:lstStyle/>
+                    <a:p>
+                      <a:pPr algn="ctr" indent="0" marL="0">
+                        <a:buNone/>
+                      </a:pPr>
+                      <a:r>
+                        <a:rPr lang="en-US" sz="800" dirty="0">
+                          <a:solidFill>
+                            <a:srgbClr val="808184"/>
+                          </a:solidFill>
+                          <a:latin typeface="Calibri" pitchFamily="34" charset="0"/>
+                          <a:ea typeface="Calibri" pitchFamily="34" charset="-122"/>
+                          <a:cs typeface="Calibri" pitchFamily="34" charset="-120"/>
+                        </a:rPr>
+                        <a:t>5</a:t>
+                      </a:r>
+                      <a:endParaRPr lang="en-US" sz="800" dirty="0">
+                        <a:latin typeface="Calibri" charset="0"/>
+                        <a:ea typeface="Calibri" charset="0"/>
+                        <a:cs typeface="Calibri" charset="0"/>
+                      </a:endParaRPr>
+                    </a:p>
+                  </a:txBody>
+                  <a:tcPr marL="91440" marR="91440" marT="45720" marB="45720" anchor="ctr">
+                    <a:lnL w="0" cap="flat" cmpd="sng" algn="ctr">
+                      <a:noFill/>
+                    </a:lnL>
+                    <a:lnR w="0" cap="flat" cmpd="sng" algn="ctr">
+                      <a:noFill/>
+                    </a:lnR>
+                    <a:lnT w="0" cap="flat" cmpd="sng" algn="ctr">
+                      <a:noFill/>
+                    </a:lnT>
+                    <a:lnB w="0" cap="flat" cmpd="sng" algn="ctr">
+                      <a:noFill/>
+                    </a:lnB>
+                    <a:solidFill>
+                      <a:srgbClr val="FFFFFF"/>
+                    </a:solidFill>
+                  </a:tcPr>
+                </a:tc>
+                <a:tc>
+                  <a:txBody>
+                    <a:bodyPr/>
+                    <a:lstStyle/>
+                    <a:p>
+                      <a:pPr indent="0" marL="0">
+                        <a:buNone/>
+                      </a:pPr>
+                      <a:r>
+                        <a:rPr lang="en-US" sz="800" b="1" dirty="0">
+                          <a:solidFill>
+                            <a:srgbClr val="3A3A3C"/>
+                          </a:solidFill>
+                          <a:latin typeface="Calibri" pitchFamily="34" charset="0"/>
+                          <a:ea typeface="Calibri" pitchFamily="34" charset="-122"/>
+                          <a:cs typeface="Calibri" pitchFamily="34" charset="-120"/>
+                        </a:rPr>
+                        <a:t>Corrective Action Recommendation Engine</a:t>
+                      </a:r>
+                      <a:endParaRPr lang="en-US" sz="800" dirty="0">
+                        <a:latin typeface="Calibri" charset="0"/>
+                        <a:ea typeface="Calibri" charset="0"/>
+                        <a:cs typeface="Calibri" charset="0"/>
+                      </a:endParaRPr>
+                    </a:p>
+                  </a:txBody>
+                  <a:tcPr marL="91440" marR="91440" marT="45720" marB="45720" anchor="ctr">
+                    <a:lnL w="0" cap="flat" cmpd="sng" algn="ctr">
+                      <a:noFill/>
+                    </a:lnL>
+                    <a:lnR w="0" cap="flat" cmpd="sng" algn="ctr">
+                      <a:noFill/>
+                    </a:lnR>
+                    <a:lnT w="0" cap="flat" cmpd="sng" algn="ctr">
+                      <a:noFill/>
+                    </a:lnT>
+                    <a:lnB w="0" cap="flat" cmpd="sng" algn="ctr">
+                      <a:noFill/>
+                    </a:lnB>
+                    <a:solidFill>
+                      <a:srgbClr val="FFFFFF"/>
+                    </a:solidFill>
+                  </a:tcPr>
+                </a:tc>
+                <a:tc>
+                  <a:txBody>
+                    <a:bodyPr/>
+                    <a:lstStyle/>
+                    <a:p>
+                      <a:pPr indent="0" marL="0">
+                        <a:buNone/>
+                      </a:pPr>
+                      <a:r>
+                        <a:rPr lang="en-US" sz="800" dirty="0">
+                          <a:solidFill>
+                            <a:srgbClr val="58595B"/>
+                          </a:solidFill>
+                          <a:latin typeface="Calibri" pitchFamily="34" charset="0"/>
+                          <a:ea typeface="Calibri" pitchFamily="34" charset="-122"/>
+                          <a:cs typeface="Calibri" pitchFamily="34" charset="-120"/>
+                        </a:rPr>
+                        <a:t>Assistive</a:t>
+                      </a:r>
+                      <a:endParaRPr lang="en-US" sz="800" dirty="0">
+                        <a:latin typeface="Calibri" charset="0"/>
+                        <a:ea typeface="Calibri" charset="0"/>
+                        <a:cs typeface="Calibri" charset="0"/>
+                      </a:endParaRPr>
+                    </a:p>
+                  </a:txBody>
+                  <a:tcPr marL="91440" marR="91440" marT="45720" marB="45720" anchor="ctr">
+                    <a:lnL w="0" cap="flat" cmpd="sng" algn="ctr">
+                      <a:noFill/>
+                    </a:lnL>
+                    <a:lnR w="0" cap="flat" cmpd="sng" algn="ctr">
+                      <a:noFill/>
+                    </a:lnR>
+                    <a:lnT w="0" cap="flat" cmpd="sng" algn="ctr">
+                      <a:noFill/>
+                    </a:lnT>
+                    <a:lnB w="0" cap="flat" cmpd="sng" algn="ctr">
+                      <a:noFill/>
+                    </a:lnB>
+                    <a:solidFill>
+                      <a:srgbClr val="FFFFFF"/>
+                    </a:solidFill>
+                  </a:tcPr>
+                </a:tc>
+                <a:tc>
+                  <a:txBody>
+                    <a:bodyPr/>
+                    <a:lstStyle/>
+                    <a:p>
+                      <a:pPr indent="0" marL="0">
+                        <a:buNone/>
+                      </a:pPr>
+                      <a:r>
+                        <a:rPr lang="en-US" sz="800" dirty="0">
+                          <a:solidFill>
+                            <a:srgbClr val="58595B"/>
+                          </a:solidFill>
+                          <a:latin typeface="Calibri" pitchFamily="34" charset="0"/>
+                          <a:ea typeface="Calibri" pitchFamily="34" charset="-122"/>
+                          <a:cs typeface="Calibri" pitchFamily="34" charset="-120"/>
+                        </a:rPr>
+                        <a:t>S5</a:t>
+                      </a:r>
+                      <a:endParaRPr lang="en-US" sz="800" dirty="0">
+                        <a:latin typeface="Calibri" charset="0"/>
+                        <a:ea typeface="Calibri" charset="0"/>
+                        <a:cs typeface="Calibri" charset="0"/>
+                      </a:endParaRPr>
+                    </a:p>
+                  </a:txBody>
+                  <a:tcPr marL="91440" marR="91440" marT="45720" marB="45720" anchor="ctr">
+                    <a:lnL w="0" cap="flat" cmpd="sng" algn="ctr">
+                      <a:noFill/>
+                    </a:lnL>
+                    <a:lnR w="0" cap="flat" cmpd="sng" algn="ctr">
+                      <a:noFill/>
+                    </a:lnR>
+                    <a:lnT w="0" cap="flat" cmpd="sng" algn="ctr">
+                      <a:noFill/>
+                    </a:lnT>
+                    <a:lnB w="0" cap="flat" cmpd="sng" algn="ctr">
+                      <a:noFill/>
+                    </a:lnB>
+                    <a:solidFill>
+                      <a:srgbClr val="FFFFFF"/>
+                    </a:solidFill>
+                  </a:tcPr>
+                </a:tc>
+                <a:tc>
+                  <a:txBody>
+                    <a:bodyPr/>
+                    <a:lstStyle/>
+                    <a:p>
+                      <a:pPr indent="0" marL="0">
+                        <a:buNone/>
+                      </a:pPr>
+                      <a:r>
+                        <a:rPr lang="en-US" sz="800" b="1" dirty="0">
+                          <a:solidFill>
+                            <a:srgbClr val="3A3A3C"/>
+                          </a:solidFill>
+                          <a:latin typeface="Calibri" pitchFamily="34" charset="0"/>
+                          <a:ea typeface="Calibri" pitchFamily="34" charset="-122"/>
+                          <a:cs typeface="Calibri" pitchFamily="34" charset="-120"/>
+                        </a:rPr>
+                        <a:t>Production</a:t>
+                      </a:r>
+                      <a:endParaRPr lang="en-US" sz="800" dirty="0">
+                        <a:latin typeface="Calibri" charset="0"/>
+                        <a:ea typeface="Calibri" charset="0"/>
+                        <a:cs typeface="Calibri" charset="0"/>
+                      </a:endParaRPr>
+                    </a:p>
+                  </a:txBody>
+                  <a:tcPr marL="91440" marR="91440" marT="45720" marB="45720" anchor="ctr">
+                    <a:lnL w="0" cap="flat" cmpd="sng" algn="ctr">
+                      <a:noFill/>
+                    </a:lnL>
+                    <a:lnR w="0" cap="flat" cmpd="sng" algn="ctr">
+                      <a:noFill/>
+                    </a:lnR>
+                    <a:lnT w="0" cap="flat" cmpd="sng" algn="ctr">
+                      <a:noFill/>
+                    </a:lnT>
+                    <a:lnB w="0" cap="flat" cmpd="sng" algn="ctr">
+                      <a:noFill/>
+                    </a:lnB>
+                    <a:solidFill>
+                      <a:srgbClr val="FFFFFF"/>
+                    </a:solidFill>
+                  </a:tcPr>
+                </a:tc>
+                <a:tc>
+                  <a:txBody>
+                    <a:bodyPr/>
+                    <a:lstStyle/>
+                    <a:p>
+                      <a:pPr indent="0" marL="0">
+                        <a:buNone/>
+                      </a:pPr>
+                      <a:r>
+                        <a:rPr lang="en-US" sz="800" dirty="0">
+                          <a:solidFill>
+                            <a:srgbClr val="58595B"/>
+                          </a:solidFill>
+                          <a:latin typeface="Calibri" pitchFamily="34" charset="0"/>
+                          <a:ea typeface="Calibri" pitchFamily="34" charset="-122"/>
+                          <a:cs typeface="Calibri" pitchFamily="34" charset="-120"/>
+                        </a:rPr>
+                        <a:t>Recommends proven corrective actions for a root cause, drawn from the Capitalization Library.</a:t>
+                      </a:r>
+                      <a:endParaRPr lang="en-US" sz="800" dirty="0">
+                        <a:latin typeface="Calibri" charset="0"/>
+                        <a:ea typeface="Calibri" charset="0"/>
+                        <a:cs typeface="Calibri" charset="0"/>
+                      </a:endParaRPr>
+                    </a:p>
+                  </a:txBody>
+                  <a:tcPr marL="91440" marR="91440" marT="45720" marB="45720" anchor="ctr">
+                    <a:lnL w="0" cap="flat" cmpd="sng" algn="ctr">
+                      <a:noFill/>
+                    </a:lnL>
+                    <a:lnR w="0" cap="flat" cmpd="sng" algn="ctr">
+                      <a:noFill/>
+                    </a:lnR>
+                    <a:lnT w="0" cap="flat" cmpd="sng" algn="ctr">
+                      <a:noFill/>
+                    </a:lnT>
+                    <a:lnB w="0" cap="flat" cmpd="sng" algn="ctr">
+                      <a:noFill/>
+                    </a:lnB>
+                    <a:solidFill>
+                      <a:srgbClr val="FFFFFF"/>
+                    </a:solidFill>
+                  </a:tcPr>
+                </a:tc>
+              </a:tr>
+              <a:tr h="290779">
+                <a:tc>
+                  <a:txBody>
+                    <a:bodyPr/>
+                    <a:lstStyle/>
+                    <a:p>
+                      <a:pPr algn="ctr" indent="0" marL="0">
+                        <a:buNone/>
+                      </a:pPr>
+                      <a:r>
+                        <a:rPr lang="en-US" sz="800" dirty="0">
+                          <a:solidFill>
+                            <a:srgbClr val="808184"/>
+                          </a:solidFill>
+                          <a:latin typeface="Calibri" pitchFamily="34" charset="0"/>
+                          <a:ea typeface="Calibri" pitchFamily="34" charset="-122"/>
+                          <a:cs typeface="Calibri" pitchFamily="34" charset="-120"/>
+                        </a:rPr>
+                        <a:t>6</a:t>
+                      </a:r>
+                      <a:endParaRPr lang="en-US" sz="800" dirty="0">
+                        <a:latin typeface="Calibri" charset="0"/>
+                        <a:ea typeface="Calibri" charset="0"/>
+                        <a:cs typeface="Calibri" charset="0"/>
+                      </a:endParaRPr>
+                    </a:p>
+                  </a:txBody>
+                  <a:tcPr marL="91440" marR="91440" marT="45720" marB="45720" anchor="ctr">
+                    <a:lnL w="0" cap="flat" cmpd="sng" algn="ctr">
+                      <a:noFill/>
+                    </a:lnL>
+                    <a:lnR w="0" cap="flat" cmpd="sng" algn="ctr">
+                      <a:noFill/>
+                    </a:lnR>
+                    <a:lnT w="0" cap="flat" cmpd="sng" algn="ctr">
+                      <a:noFill/>
+                    </a:lnT>
+                    <a:lnB w="0" cap="flat" cmpd="sng" algn="ctr">
+                      <a:noFill/>
+                    </a:lnB>
+                    <a:solidFill>
+                      <a:srgbClr val="F2F2F3"/>
+                    </a:solidFill>
+                  </a:tcPr>
+                </a:tc>
+                <a:tc>
+                  <a:txBody>
+                    <a:bodyPr/>
+                    <a:lstStyle/>
+                    <a:p>
+                      <a:pPr indent="0" marL="0">
+                        <a:buNone/>
+                      </a:pPr>
+                      <a:r>
+                        <a:rPr lang="en-US" sz="800" b="1" dirty="0">
+                          <a:solidFill>
+                            <a:srgbClr val="3A3A3C"/>
+                          </a:solidFill>
+                          <a:latin typeface="Calibri" pitchFamily="34" charset="0"/>
+                          <a:ea typeface="Calibri" pitchFamily="34" charset="-122"/>
+                          <a:cs typeface="Calibri" pitchFamily="34" charset="-120"/>
+                        </a:rPr>
+                        <a:t>Corrective Action Effectiveness Evaluation Assistant</a:t>
+                      </a:r>
+                      <a:endParaRPr lang="en-US" sz="800" dirty="0">
+                        <a:latin typeface="Calibri" charset="0"/>
+                        <a:ea typeface="Calibri" charset="0"/>
+                        <a:cs typeface="Calibri" charset="0"/>
+                      </a:endParaRPr>
+                    </a:p>
+                  </a:txBody>
+                  <a:tcPr marL="91440" marR="91440" marT="45720" marB="45720" anchor="ctr">
+                    <a:lnL w="0" cap="flat" cmpd="sng" algn="ctr">
+                      <a:noFill/>
+                    </a:lnL>
+                    <a:lnR w="0" cap="flat" cmpd="sng" algn="ctr">
+                      <a:noFill/>
+                    </a:lnR>
+                    <a:lnT w="0" cap="flat" cmpd="sng" algn="ctr">
+                      <a:noFill/>
+                    </a:lnT>
+                    <a:lnB w="0" cap="flat" cmpd="sng" algn="ctr">
+                      <a:noFill/>
+                    </a:lnB>
+                    <a:solidFill>
+                      <a:srgbClr val="F2F2F3"/>
+                    </a:solidFill>
+                  </a:tcPr>
+                </a:tc>
+                <a:tc>
+                  <a:txBody>
+                    <a:bodyPr/>
+                    <a:lstStyle/>
+                    <a:p>
+                      <a:pPr indent="0" marL="0">
+                        <a:buNone/>
+                      </a:pPr>
+                      <a:r>
+                        <a:rPr lang="en-US" sz="800" dirty="0">
+                          <a:solidFill>
+                            <a:srgbClr val="58595B"/>
+                          </a:solidFill>
+                          <a:latin typeface="Calibri" pitchFamily="34" charset="0"/>
+                          <a:ea typeface="Calibri" pitchFamily="34" charset="-122"/>
+                          <a:cs typeface="Calibri" pitchFamily="34" charset="-120"/>
+                        </a:rPr>
+                        <a:t>Assistive</a:t>
+                      </a:r>
+                      <a:endParaRPr lang="en-US" sz="800" dirty="0">
+                        <a:latin typeface="Calibri" charset="0"/>
+                        <a:ea typeface="Calibri" charset="0"/>
+                        <a:cs typeface="Calibri" charset="0"/>
+                      </a:endParaRPr>
+                    </a:p>
+                  </a:txBody>
+                  <a:tcPr marL="91440" marR="91440" marT="45720" marB="45720" anchor="ctr">
+                    <a:lnL w="0" cap="flat" cmpd="sng" algn="ctr">
+                      <a:noFill/>
+                    </a:lnL>
+                    <a:lnR w="0" cap="flat" cmpd="sng" algn="ctr">
+                      <a:noFill/>
+                    </a:lnR>
+                    <a:lnT w="0" cap="flat" cmpd="sng" algn="ctr">
+                      <a:noFill/>
+                    </a:lnT>
+                    <a:lnB w="0" cap="flat" cmpd="sng" algn="ctr">
+                      <a:noFill/>
+                    </a:lnB>
+                    <a:solidFill>
+                      <a:srgbClr val="F2F2F3"/>
+                    </a:solidFill>
+                  </a:tcPr>
+                </a:tc>
+                <a:tc>
+                  <a:txBody>
+                    <a:bodyPr/>
+                    <a:lstStyle/>
+                    <a:p>
+                      <a:pPr indent="0" marL="0">
+                        <a:buNone/>
+                      </a:pPr>
+                      <a:r>
+                        <a:rPr lang="en-US" sz="800" dirty="0">
+                          <a:solidFill>
+                            <a:srgbClr val="58595B"/>
+                          </a:solidFill>
+                          <a:latin typeface="Calibri" pitchFamily="34" charset="0"/>
+                          <a:ea typeface="Calibri" pitchFamily="34" charset="-122"/>
+                          <a:cs typeface="Calibri" pitchFamily="34" charset="-120"/>
+                        </a:rPr>
+                        <a:t>S6</a:t>
+                      </a:r>
+                      <a:endParaRPr lang="en-US" sz="800" dirty="0">
+                        <a:latin typeface="Calibri" charset="0"/>
+                        <a:ea typeface="Calibri" charset="0"/>
+                        <a:cs typeface="Calibri" charset="0"/>
+                      </a:endParaRPr>
+                    </a:p>
+                  </a:txBody>
+                  <a:tcPr marL="91440" marR="91440" marT="45720" marB="45720" anchor="ctr">
+                    <a:lnL w="0" cap="flat" cmpd="sng" algn="ctr">
+                      <a:noFill/>
+                    </a:lnL>
+                    <a:lnR w="0" cap="flat" cmpd="sng" algn="ctr">
+                      <a:noFill/>
+                    </a:lnR>
+                    <a:lnT w="0" cap="flat" cmpd="sng" algn="ctr">
+                      <a:noFill/>
+                    </a:lnT>
+                    <a:lnB w="0" cap="flat" cmpd="sng" algn="ctr">
+                      <a:noFill/>
+                    </a:lnB>
+                    <a:solidFill>
+                      <a:srgbClr val="F2F2F3"/>
+                    </a:solidFill>
+                  </a:tcPr>
+                </a:tc>
+                <a:tc>
+                  <a:txBody>
+                    <a:bodyPr/>
+                    <a:lstStyle/>
+                    <a:p>
+                      <a:pPr indent="0" marL="0">
+                        <a:buNone/>
+                      </a:pPr>
+                      <a:r>
+                        <a:rPr lang="en-US" sz="800" b="1" dirty="0">
+                          <a:solidFill>
+                            <a:srgbClr val="3A3A3C"/>
+                          </a:solidFill>
+                          <a:latin typeface="Calibri" pitchFamily="34" charset="0"/>
+                          <a:ea typeface="Calibri" pitchFamily="34" charset="-122"/>
+                          <a:cs typeface="Calibri" pitchFamily="34" charset="-120"/>
+                        </a:rPr>
+                        <a:t>Production</a:t>
+                      </a:r>
+                      <a:endParaRPr lang="en-US" sz="800" dirty="0">
+                        <a:latin typeface="Calibri" charset="0"/>
+                        <a:ea typeface="Calibri" charset="0"/>
+                        <a:cs typeface="Calibri" charset="0"/>
+                      </a:endParaRPr>
+                    </a:p>
+                  </a:txBody>
+                  <a:tcPr marL="91440" marR="91440" marT="45720" marB="45720" anchor="ctr">
+                    <a:lnL w="0" cap="flat" cmpd="sng" algn="ctr">
+                      <a:noFill/>
+                    </a:lnL>
+                    <a:lnR w="0" cap="flat" cmpd="sng" algn="ctr">
+                      <a:noFill/>
+                    </a:lnR>
+                    <a:lnT w="0" cap="flat" cmpd="sng" algn="ctr">
+                      <a:noFill/>
+                    </a:lnT>
+                    <a:lnB w="0" cap="flat" cmpd="sng" algn="ctr">
+                      <a:noFill/>
+                    </a:lnB>
+                    <a:solidFill>
+                      <a:srgbClr val="F2F2F3"/>
+                    </a:solidFill>
+                  </a:tcPr>
+                </a:tc>
+                <a:tc>
+                  <a:txBody>
+                    <a:bodyPr/>
+                    <a:lstStyle/>
+                    <a:p>
+                      <a:pPr indent="0" marL="0">
+                        <a:buNone/>
+                      </a:pPr>
+                      <a:r>
+                        <a:rPr lang="en-US" sz="800" dirty="0">
+                          <a:solidFill>
+                            <a:srgbClr val="58595B"/>
+                          </a:solidFill>
+                          <a:latin typeface="Calibri" pitchFamily="34" charset="0"/>
+                          <a:ea typeface="Calibri" pitchFamily="34" charset="-122"/>
+                          <a:cs typeface="Calibri" pitchFamily="34" charset="-120"/>
+                        </a:rPr>
+                        <a:t>Surfaces the root cause to re-verify and the org's historical effectiveness rate.</a:t>
+                      </a:r>
+                      <a:endParaRPr lang="en-US" sz="800" dirty="0">
+                        <a:latin typeface="Calibri" charset="0"/>
+                        <a:ea typeface="Calibri" charset="0"/>
+                        <a:cs typeface="Calibri" charset="0"/>
+                      </a:endParaRPr>
+                    </a:p>
+                  </a:txBody>
+                  <a:tcPr marL="91440" marR="91440" marT="45720" marB="45720" anchor="ctr">
+                    <a:lnL w="0" cap="flat" cmpd="sng" algn="ctr">
+                      <a:noFill/>
+                    </a:lnL>
+                    <a:lnR w="0" cap="flat" cmpd="sng" algn="ctr">
+                      <a:noFill/>
+                    </a:lnR>
+                    <a:lnT w="0" cap="flat" cmpd="sng" algn="ctr">
+                      <a:noFill/>
+                    </a:lnT>
+                    <a:lnB w="0" cap="flat" cmpd="sng" algn="ctr">
+                      <a:noFill/>
+                    </a:lnB>
+                    <a:solidFill>
+                      <a:srgbClr val="F2F2F3"/>
+                    </a:solidFill>
+                  </a:tcPr>
+                </a:tc>
+              </a:tr>
+              <a:tr h="290779">
+                <a:tc>
+                  <a:txBody>
+                    <a:bodyPr/>
+                    <a:lstStyle/>
+                    <a:p>
+                      <a:pPr algn="ctr" indent="0" marL="0">
+                        <a:buNone/>
+                      </a:pPr>
+                      <a:r>
+                        <a:rPr lang="en-US" sz="800" dirty="0">
+                          <a:solidFill>
+                            <a:srgbClr val="808184"/>
+                          </a:solidFill>
+                          <a:latin typeface="Calibri" pitchFamily="34" charset="0"/>
+                          <a:ea typeface="Calibri" pitchFamily="34" charset="-122"/>
+                          <a:cs typeface="Calibri" pitchFamily="34" charset="-120"/>
+                        </a:rPr>
+                        <a:t>7</a:t>
+                      </a:r>
+                      <a:endParaRPr lang="en-US" sz="800" dirty="0">
+                        <a:latin typeface="Calibri" charset="0"/>
+                        <a:ea typeface="Calibri" charset="0"/>
+                        <a:cs typeface="Calibri" charset="0"/>
+                      </a:endParaRPr>
+                    </a:p>
+                  </a:txBody>
+                  <a:tcPr marL="91440" marR="91440" marT="45720" marB="45720" anchor="ctr">
+                    <a:lnL w="0" cap="flat" cmpd="sng" algn="ctr">
+                      <a:noFill/>
+                    </a:lnL>
+                    <a:lnR w="0" cap="flat" cmpd="sng" algn="ctr">
+                      <a:noFill/>
+                    </a:lnR>
+                    <a:lnT w="0" cap="flat" cmpd="sng" algn="ctr">
+                      <a:noFill/>
+                    </a:lnT>
+                    <a:lnB w="0" cap="flat" cmpd="sng" algn="ctr">
+                      <a:noFill/>
+                    </a:lnB>
+                    <a:solidFill>
+                      <a:srgbClr val="FFFFFF"/>
+                    </a:solidFill>
+                  </a:tcPr>
+                </a:tc>
+                <a:tc>
+                  <a:txBody>
+                    <a:bodyPr/>
+                    <a:lstStyle/>
+                    <a:p>
+                      <a:pPr indent="0" marL="0">
+                        <a:buNone/>
+                      </a:pPr>
+                      <a:r>
+                        <a:rPr lang="en-US" sz="800" b="1" dirty="0">
+                          <a:solidFill>
+                            <a:srgbClr val="3A3A3C"/>
+                          </a:solidFill>
+                          <a:latin typeface="Calibri" pitchFamily="34" charset="0"/>
+                          <a:ea typeface="Calibri" pitchFamily="34" charset="-122"/>
+                          <a:cs typeface="Calibri" pitchFamily="34" charset="-120"/>
+                        </a:rPr>
+                        <a:t>REX (Lessons-Learned) Drafting Assistant</a:t>
+                      </a:r>
+                      <a:endParaRPr lang="en-US" sz="800" dirty="0">
+                        <a:latin typeface="Calibri" charset="0"/>
+                        <a:ea typeface="Calibri" charset="0"/>
+                        <a:cs typeface="Calibri" charset="0"/>
+                      </a:endParaRPr>
+                    </a:p>
+                  </a:txBody>
+                  <a:tcPr marL="91440" marR="91440" marT="45720" marB="45720" anchor="ctr">
+                    <a:lnL w="0" cap="flat" cmpd="sng" algn="ctr">
+                      <a:noFill/>
+                    </a:lnL>
+                    <a:lnR w="0" cap="flat" cmpd="sng" algn="ctr">
+                      <a:noFill/>
+                    </a:lnR>
+                    <a:lnT w="0" cap="flat" cmpd="sng" algn="ctr">
+                      <a:noFill/>
+                    </a:lnT>
+                    <a:lnB w="0" cap="flat" cmpd="sng" algn="ctr">
+                      <a:noFill/>
+                    </a:lnB>
+                    <a:solidFill>
+                      <a:srgbClr val="FFFFFF"/>
+                    </a:solidFill>
+                  </a:tcPr>
+                </a:tc>
+                <a:tc>
+                  <a:txBody>
+                    <a:bodyPr/>
+                    <a:lstStyle/>
+                    <a:p>
+                      <a:pPr indent="0" marL="0">
+                        <a:buNone/>
+                      </a:pPr>
+                      <a:r>
+                        <a:rPr lang="en-US" sz="800" b="1" dirty="0">
+                          <a:solidFill>
+                            <a:srgbClr val="E07B00"/>
+                          </a:solidFill>
+                          <a:latin typeface="Calibri" pitchFamily="34" charset="0"/>
+                          <a:ea typeface="Calibri" pitchFamily="34" charset="-122"/>
+                          <a:cs typeface="Calibri" pitchFamily="34" charset="-120"/>
+                        </a:rPr>
+                        <a:t>Augmented</a:t>
+                      </a:r>
+                      <a:endParaRPr lang="en-US" sz="800" dirty="0">
+                        <a:latin typeface="Calibri" charset="0"/>
+                        <a:ea typeface="Calibri" charset="0"/>
+                        <a:cs typeface="Calibri" charset="0"/>
+                      </a:endParaRPr>
+                    </a:p>
+                  </a:txBody>
+                  <a:tcPr marL="91440" marR="91440" marT="45720" marB="45720" anchor="ctr">
+                    <a:lnL w="0" cap="flat" cmpd="sng" algn="ctr">
+                      <a:noFill/>
+                    </a:lnL>
+                    <a:lnR w="0" cap="flat" cmpd="sng" algn="ctr">
+                      <a:noFill/>
+                    </a:lnR>
+                    <a:lnT w="0" cap="flat" cmpd="sng" algn="ctr">
+                      <a:noFill/>
+                    </a:lnT>
+                    <a:lnB w="0" cap="flat" cmpd="sng" algn="ctr">
+                      <a:noFill/>
+                    </a:lnB>
+                    <a:solidFill>
+                      <a:srgbClr val="FFFFFF"/>
+                    </a:solidFill>
+                  </a:tcPr>
+                </a:tc>
+                <a:tc>
+                  <a:txBody>
+                    <a:bodyPr/>
+                    <a:lstStyle/>
+                    <a:p>
+                      <a:pPr indent="0" marL="0">
+                        <a:buNone/>
+                      </a:pPr>
+                      <a:r>
+                        <a:rPr lang="en-US" sz="800" dirty="0">
+                          <a:solidFill>
+                            <a:srgbClr val="58595B"/>
+                          </a:solidFill>
+                          <a:latin typeface="Calibri" pitchFamily="34" charset="0"/>
+                          <a:ea typeface="Calibri" pitchFamily="34" charset="-122"/>
+                          <a:cs typeface="Calibri" pitchFamily="34" charset="-120"/>
+                        </a:rPr>
+                        <a:t>S7</a:t>
+                      </a:r>
+                      <a:endParaRPr lang="en-US" sz="800" dirty="0">
+                        <a:latin typeface="Calibri" charset="0"/>
+                        <a:ea typeface="Calibri" charset="0"/>
+                        <a:cs typeface="Calibri" charset="0"/>
+                      </a:endParaRPr>
+                    </a:p>
+                  </a:txBody>
+                  <a:tcPr marL="91440" marR="91440" marT="45720" marB="45720" anchor="ctr">
+                    <a:lnL w="0" cap="flat" cmpd="sng" algn="ctr">
+                      <a:noFill/>
+                    </a:lnL>
+                    <a:lnR w="0" cap="flat" cmpd="sng" algn="ctr">
+                      <a:noFill/>
+                    </a:lnR>
+                    <a:lnT w="0" cap="flat" cmpd="sng" algn="ctr">
+                      <a:noFill/>
+                    </a:lnT>
+                    <a:lnB w="0" cap="flat" cmpd="sng" algn="ctr">
+                      <a:noFill/>
+                    </a:lnB>
+                    <a:solidFill>
+                      <a:srgbClr val="FFFFFF"/>
+                    </a:solidFill>
+                  </a:tcPr>
+                </a:tc>
+                <a:tc>
+                  <a:txBody>
+                    <a:bodyPr/>
+                    <a:lstStyle/>
+                    <a:p>
+                      <a:pPr indent="0" marL="0">
+                        <a:buNone/>
+                      </a:pPr>
+                      <a:r>
+                        <a:rPr lang="en-US" sz="800" b="1" dirty="0">
+                          <a:solidFill>
+                            <a:srgbClr val="3A3A3C"/>
+                          </a:solidFill>
+                          <a:latin typeface="Calibri" pitchFamily="34" charset="0"/>
+                          <a:ea typeface="Calibri" pitchFamily="34" charset="-122"/>
+                          <a:cs typeface="Calibri" pitchFamily="34" charset="-120"/>
+                        </a:rPr>
+                        <a:t>Production</a:t>
+                      </a:r>
+                      <a:endParaRPr lang="en-US" sz="800" dirty="0">
+                        <a:latin typeface="Calibri" charset="0"/>
+                        <a:ea typeface="Calibri" charset="0"/>
+                        <a:cs typeface="Calibri" charset="0"/>
+                      </a:endParaRPr>
+                    </a:p>
+                  </a:txBody>
+                  <a:tcPr marL="91440" marR="91440" marT="45720" marB="45720" anchor="ctr">
+                    <a:lnL w="0" cap="flat" cmpd="sng" algn="ctr">
+                      <a:noFill/>
+                    </a:lnL>
+                    <a:lnR w="0" cap="flat" cmpd="sng" algn="ctr">
+                      <a:noFill/>
+                    </a:lnR>
+                    <a:lnT w="0" cap="flat" cmpd="sng" algn="ctr">
+                      <a:noFill/>
+                    </a:lnT>
+                    <a:lnB w="0" cap="flat" cmpd="sng" algn="ctr">
+                      <a:noFill/>
+                    </a:lnB>
+                    <a:solidFill>
+                      <a:srgbClr val="FFFFFF"/>
+                    </a:solidFill>
+                  </a:tcPr>
+                </a:tc>
+                <a:tc>
+                  <a:txBody>
+                    <a:bodyPr/>
+                    <a:lstStyle/>
+                    <a:p>
+                      <a:pPr indent="0" marL="0">
+                        <a:buNone/>
+                      </a:pPr>
+                      <a:r>
+                        <a:rPr lang="en-US" sz="800" dirty="0">
+                          <a:solidFill>
+                            <a:srgbClr val="58595B"/>
+                          </a:solidFill>
+                          <a:latin typeface="Calibri" pitchFamily="34" charset="0"/>
+                          <a:ea typeface="Calibri" pitchFamily="34" charset="-122"/>
+                          <a:cs typeface="Calibri" pitchFamily="34" charset="-120"/>
+                        </a:rPr>
+                        <a:t>Drafts the REX narrative — lessons learned and standardization — from the Sheet's S1-S6 content.</a:t>
+                      </a:r>
+                      <a:endParaRPr lang="en-US" sz="800" dirty="0">
+                        <a:latin typeface="Calibri" charset="0"/>
+                        <a:ea typeface="Calibri" charset="0"/>
+                        <a:cs typeface="Calibri" charset="0"/>
+                      </a:endParaRPr>
+                    </a:p>
+                  </a:txBody>
+                  <a:tcPr marL="91440" marR="91440" marT="45720" marB="45720" anchor="ctr">
+                    <a:lnL w="0" cap="flat" cmpd="sng" algn="ctr">
+                      <a:noFill/>
+                    </a:lnL>
+                    <a:lnR w="0" cap="flat" cmpd="sng" algn="ctr">
+                      <a:noFill/>
+                    </a:lnR>
+                    <a:lnT w="0" cap="flat" cmpd="sng" algn="ctr">
+                      <a:noFill/>
+                    </a:lnT>
+                    <a:lnB w="0" cap="flat" cmpd="sng" algn="ctr">
+                      <a:noFill/>
+                    </a:lnB>
+                    <a:solidFill>
+                      <a:srgbClr val="FFFFFF"/>
+                    </a:solidFill>
+                  </a:tcPr>
+                </a:tc>
+              </a:tr>
+              <a:tr h="290779">
+                <a:tc>
+                  <a:txBody>
+                    <a:bodyPr/>
+                    <a:lstStyle/>
+                    <a:p>
+                      <a:pPr algn="ctr" indent="0" marL="0">
+                        <a:buNone/>
+                      </a:pPr>
+                      <a:r>
+                        <a:rPr lang="en-US" sz="800" dirty="0">
+                          <a:solidFill>
+                            <a:srgbClr val="808184"/>
+                          </a:solidFill>
+                          <a:latin typeface="Calibri" pitchFamily="34" charset="0"/>
+                          <a:ea typeface="Calibri" pitchFamily="34" charset="-122"/>
+                          <a:cs typeface="Calibri" pitchFamily="34" charset="-120"/>
+                        </a:rPr>
+                        <a:t>8</a:t>
+                      </a:r>
+                      <a:endParaRPr lang="en-US" sz="800" dirty="0">
+                        <a:latin typeface="Calibri" charset="0"/>
+                        <a:ea typeface="Calibri" charset="0"/>
+                        <a:cs typeface="Calibri" charset="0"/>
+                      </a:endParaRPr>
+                    </a:p>
+                  </a:txBody>
+                  <a:tcPr marL="91440" marR="91440" marT="45720" marB="45720" anchor="ctr">
+                    <a:lnL w="0" cap="flat" cmpd="sng" algn="ctr">
+                      <a:noFill/>
+                    </a:lnL>
+                    <a:lnR w="0" cap="flat" cmpd="sng" algn="ctr">
+                      <a:noFill/>
+                    </a:lnR>
+                    <a:lnT w="0" cap="flat" cmpd="sng" algn="ctr">
+                      <a:noFill/>
+                    </a:lnT>
+                    <a:lnB w="0" cap="flat" cmpd="sng" algn="ctr">
+                      <a:noFill/>
+                    </a:lnB>
+                    <a:solidFill>
+                      <a:srgbClr val="F2F2F3"/>
+                    </a:solidFill>
+                  </a:tcPr>
+                </a:tc>
+                <a:tc>
+                  <a:txBody>
+                    <a:bodyPr/>
+                    <a:lstStyle/>
+                    <a:p>
+                      <a:pPr indent="0" marL="0">
+                        <a:buNone/>
+                      </a:pPr>
+                      <a:r>
+                        <a:rPr lang="en-US" sz="800" b="1" dirty="0">
+                          <a:solidFill>
+                            <a:srgbClr val="3A3A3C"/>
+                          </a:solidFill>
+                          <a:latin typeface="Calibri" pitchFamily="34" charset="0"/>
+                          <a:ea typeface="Calibri" pitchFamily="34" charset="-122"/>
+                          <a:cs typeface="Calibri" pitchFamily="34" charset="-120"/>
+                        </a:rPr>
+                        <a:t>Data Query Assistant</a:t>
+                      </a:r>
+                      <a:endParaRPr lang="en-US" sz="800" dirty="0">
+                        <a:latin typeface="Calibri" charset="0"/>
+                        <a:ea typeface="Calibri" charset="0"/>
+                        <a:cs typeface="Calibri" charset="0"/>
+                      </a:endParaRPr>
+                    </a:p>
+                  </a:txBody>
+                  <a:tcPr marL="91440" marR="91440" marT="45720" marB="45720" anchor="ctr">
+                    <a:lnL w="0" cap="flat" cmpd="sng" algn="ctr">
+                      <a:noFill/>
+                    </a:lnL>
+                    <a:lnR w="0" cap="flat" cmpd="sng" algn="ctr">
+                      <a:noFill/>
+                    </a:lnR>
+                    <a:lnT w="0" cap="flat" cmpd="sng" algn="ctr">
+                      <a:noFill/>
+                    </a:lnT>
+                    <a:lnB w="0" cap="flat" cmpd="sng" algn="ctr">
+                      <a:noFill/>
+                    </a:lnB>
+                    <a:solidFill>
+                      <a:srgbClr val="F2F2F3"/>
+                    </a:solidFill>
+                  </a:tcPr>
+                </a:tc>
+                <a:tc>
+                  <a:txBody>
+                    <a:bodyPr/>
+                    <a:lstStyle/>
+                    <a:p>
+                      <a:pPr indent="0" marL="0">
+                        <a:buNone/>
+                      </a:pPr>
+                      <a:r>
+                        <a:rPr lang="en-US" sz="800" dirty="0">
+                          <a:solidFill>
+                            <a:srgbClr val="58595B"/>
+                          </a:solidFill>
+                          <a:latin typeface="Calibri" pitchFamily="34" charset="0"/>
+                          <a:ea typeface="Calibri" pitchFamily="34" charset="-122"/>
+                          <a:cs typeface="Calibri" pitchFamily="34" charset="-120"/>
+                        </a:rPr>
+                        <a:t>Assistive</a:t>
+                      </a:r>
+                      <a:endParaRPr lang="en-US" sz="800" dirty="0">
+                        <a:latin typeface="Calibri" charset="0"/>
+                        <a:ea typeface="Calibri" charset="0"/>
+                        <a:cs typeface="Calibri" charset="0"/>
+                      </a:endParaRPr>
+                    </a:p>
+                  </a:txBody>
+                  <a:tcPr marL="91440" marR="91440" marT="45720" marB="45720" anchor="ctr">
+                    <a:lnL w="0" cap="flat" cmpd="sng" algn="ctr">
+                      <a:noFill/>
+                    </a:lnL>
+                    <a:lnR w="0" cap="flat" cmpd="sng" algn="ctr">
+                      <a:noFill/>
+                    </a:lnR>
+                    <a:lnT w="0" cap="flat" cmpd="sng" algn="ctr">
+                      <a:noFill/>
+                    </a:lnT>
+                    <a:lnB w="0" cap="flat" cmpd="sng" algn="ctr">
+                      <a:noFill/>
+                    </a:lnB>
+                    <a:solidFill>
+                      <a:srgbClr val="F2F2F3"/>
+                    </a:solidFill>
+                  </a:tcPr>
+                </a:tc>
+                <a:tc>
+                  <a:txBody>
+                    <a:bodyPr/>
+                    <a:lstStyle/>
+                    <a:p>
+                      <a:pPr indent="0" marL="0">
+                        <a:buNone/>
+                      </a:pPr>
+                      <a:r>
+                        <a:rPr lang="en-US" sz="800" dirty="0">
+                          <a:solidFill>
+                            <a:srgbClr val="58595B"/>
+                          </a:solidFill>
+                          <a:latin typeface="Calibri" pitchFamily="34" charset="0"/>
+                          <a:ea typeface="Calibri" pitchFamily="34" charset="-122"/>
+                          <a:cs typeface="Calibri" pitchFamily="34" charset="-120"/>
+                        </a:rPr>
+                        <a:t>AI Assistant</a:t>
+                      </a:r>
+                      <a:endParaRPr lang="en-US" sz="800" dirty="0">
+                        <a:latin typeface="Calibri" charset="0"/>
+                        <a:ea typeface="Calibri" charset="0"/>
+                        <a:cs typeface="Calibri" charset="0"/>
+                      </a:endParaRPr>
+                    </a:p>
+                  </a:txBody>
+                  <a:tcPr marL="91440" marR="91440" marT="45720" marB="45720" anchor="ctr">
+                    <a:lnL w="0" cap="flat" cmpd="sng" algn="ctr">
+                      <a:noFill/>
+                    </a:lnL>
+                    <a:lnR w="0" cap="flat" cmpd="sng" algn="ctr">
+                      <a:noFill/>
+                    </a:lnR>
+                    <a:lnT w="0" cap="flat" cmpd="sng" algn="ctr">
+                      <a:noFill/>
+                    </a:lnT>
+                    <a:lnB w="0" cap="flat" cmpd="sng" algn="ctr">
+                      <a:noFill/>
+                    </a:lnB>
+                    <a:solidFill>
+                      <a:srgbClr val="F2F2F3"/>
+                    </a:solidFill>
+                  </a:tcPr>
+                </a:tc>
+                <a:tc>
+                  <a:txBody>
+                    <a:bodyPr/>
+                    <a:lstStyle/>
+                    <a:p>
+                      <a:pPr indent="0" marL="0">
+                        <a:buNone/>
+                      </a:pPr>
+                      <a:r>
+                        <a:rPr lang="en-US" sz="800" b="1" dirty="0">
+                          <a:solidFill>
+                            <a:srgbClr val="3A3A3C"/>
+                          </a:solidFill>
+                          <a:latin typeface="Calibri" pitchFamily="34" charset="0"/>
+                          <a:ea typeface="Calibri" pitchFamily="34" charset="-122"/>
+                          <a:cs typeface="Calibri" pitchFamily="34" charset="-120"/>
+                        </a:rPr>
+                        <a:t>Production</a:t>
+                      </a:r>
+                      <a:endParaRPr lang="en-US" sz="800" dirty="0">
+                        <a:latin typeface="Calibri" charset="0"/>
+                        <a:ea typeface="Calibri" charset="0"/>
+                        <a:cs typeface="Calibri" charset="0"/>
+                      </a:endParaRPr>
+                    </a:p>
+                  </a:txBody>
+                  <a:tcPr marL="91440" marR="91440" marT="45720" marB="45720" anchor="ctr">
+                    <a:lnL w="0" cap="flat" cmpd="sng" algn="ctr">
+                      <a:noFill/>
+                    </a:lnL>
+                    <a:lnR w="0" cap="flat" cmpd="sng" algn="ctr">
+                      <a:noFill/>
+                    </a:lnR>
+                    <a:lnT w="0" cap="flat" cmpd="sng" algn="ctr">
+                      <a:noFill/>
+                    </a:lnT>
+                    <a:lnB w="0" cap="flat" cmpd="sng" algn="ctr">
+                      <a:noFill/>
+                    </a:lnB>
+                    <a:solidFill>
+                      <a:srgbClr val="F2F2F3"/>
+                    </a:solidFill>
+                  </a:tcPr>
+                </a:tc>
+                <a:tc>
+                  <a:txBody>
+                    <a:bodyPr/>
+                    <a:lstStyle/>
+                    <a:p>
+                      <a:pPr indent="0" marL="0">
+                        <a:buNone/>
+                      </a:pPr>
+                      <a:r>
+                        <a:rPr lang="en-US" sz="800" dirty="0">
+                          <a:solidFill>
+                            <a:srgbClr val="58595B"/>
+                          </a:solidFill>
+                          <a:latin typeface="Calibri" pitchFamily="34" charset="0"/>
+                          <a:ea typeface="Calibri" pitchFamily="34" charset="-122"/>
+                          <a:cs typeface="Calibri" pitchFamily="34" charset="-120"/>
+                        </a:rPr>
+                        <a:t>Answers plain-language questions about the org's own data, scoped to the user's role.</a:t>
+                      </a:r>
+                      <a:endParaRPr lang="en-US" sz="800" dirty="0">
+                        <a:latin typeface="Calibri" charset="0"/>
+                        <a:ea typeface="Calibri" charset="0"/>
+                        <a:cs typeface="Calibri" charset="0"/>
+                      </a:endParaRPr>
+                    </a:p>
+                  </a:txBody>
+                  <a:tcPr marL="91440" marR="91440" marT="45720" marB="45720" anchor="ctr">
+                    <a:lnL w="0" cap="flat" cmpd="sng" algn="ctr">
+                      <a:noFill/>
+                    </a:lnL>
+                    <a:lnR w="0" cap="flat" cmpd="sng" algn="ctr">
+                      <a:noFill/>
+                    </a:lnR>
+                    <a:lnT w="0" cap="flat" cmpd="sng" algn="ctr">
+                      <a:noFill/>
+                    </a:lnT>
+                    <a:lnB w="0" cap="flat" cmpd="sng" algn="ctr">
+                      <a:noFill/>
+                    </a:lnB>
+                    <a:solidFill>
+                      <a:srgbClr val="F2F2F3"/>
+                    </a:solidFill>
+                  </a:tcPr>
+                </a:tc>
+              </a:tr>
+              <a:tr h="290779">
+                <a:tc>
+                  <a:txBody>
+                    <a:bodyPr/>
+                    <a:lstStyle/>
+                    <a:p>
+                      <a:pPr algn="ctr" indent="0" marL="0">
+                        <a:buNone/>
+                      </a:pPr>
+                      <a:r>
+                        <a:rPr lang="en-US" sz="800" dirty="0">
+                          <a:solidFill>
+                            <a:srgbClr val="808184"/>
+                          </a:solidFill>
+                          <a:latin typeface="Calibri" pitchFamily="34" charset="0"/>
+                          <a:ea typeface="Calibri" pitchFamily="34" charset="-122"/>
+                          <a:cs typeface="Calibri" pitchFamily="34" charset="-120"/>
+                        </a:rPr>
+                        <a:t>9</a:t>
+                      </a:r>
+                      <a:endParaRPr lang="en-US" sz="800" dirty="0">
+                        <a:latin typeface="Calibri" charset="0"/>
+                        <a:ea typeface="Calibri" charset="0"/>
+                        <a:cs typeface="Calibri" charset="0"/>
+                      </a:endParaRPr>
+                    </a:p>
+                  </a:txBody>
+                  <a:tcPr marL="91440" marR="91440" marT="45720" marB="45720" anchor="ctr">
+                    <a:lnL w="0" cap="flat" cmpd="sng" algn="ctr">
+                      <a:noFill/>
+                    </a:lnL>
+                    <a:lnR w="0" cap="flat" cmpd="sng" algn="ctr">
+                      <a:noFill/>
+                    </a:lnR>
+                    <a:lnT w="0" cap="flat" cmpd="sng" algn="ctr">
+                      <a:noFill/>
+                    </a:lnT>
+                    <a:lnB w="0" cap="flat" cmpd="sng" algn="ctr">
+                      <a:noFill/>
+                    </a:lnB>
+                    <a:solidFill>
+                      <a:srgbClr val="FFFFFF"/>
+                    </a:solidFill>
+                  </a:tcPr>
+                </a:tc>
+                <a:tc>
+                  <a:txBody>
+                    <a:bodyPr/>
+                    <a:lstStyle/>
+                    <a:p>
+                      <a:pPr indent="0" marL="0">
+                        <a:buNone/>
+                      </a:pPr>
+                      <a:r>
+                        <a:rPr lang="en-US" sz="800" b="1" dirty="0">
+                          <a:solidFill>
+                            <a:srgbClr val="3A3A3C"/>
+                          </a:solidFill>
+                          <a:latin typeface="Calibri" pitchFamily="34" charset="0"/>
+                          <a:ea typeface="Calibri" pitchFamily="34" charset="-122"/>
+                          <a:cs typeface="Calibri" pitchFamily="34" charset="-120"/>
+                        </a:rPr>
+                        <a:t>Application Help Assistant</a:t>
+                      </a:r>
+                      <a:endParaRPr lang="en-US" sz="800" dirty="0">
+                        <a:latin typeface="Calibri" charset="0"/>
+                        <a:ea typeface="Calibri" charset="0"/>
+                        <a:cs typeface="Calibri" charset="0"/>
+                      </a:endParaRPr>
+                    </a:p>
+                  </a:txBody>
+                  <a:tcPr marL="91440" marR="91440" marT="45720" marB="45720" anchor="ctr">
+                    <a:lnL w="0" cap="flat" cmpd="sng" algn="ctr">
+                      <a:noFill/>
+                    </a:lnL>
+                    <a:lnR w="0" cap="flat" cmpd="sng" algn="ctr">
+                      <a:noFill/>
+                    </a:lnR>
+                    <a:lnT w="0" cap="flat" cmpd="sng" algn="ctr">
+                      <a:noFill/>
+                    </a:lnT>
+                    <a:lnB w="0" cap="flat" cmpd="sng" algn="ctr">
+                      <a:noFill/>
+                    </a:lnB>
+                    <a:solidFill>
+                      <a:srgbClr val="FFFFFF"/>
+                    </a:solidFill>
+                  </a:tcPr>
+                </a:tc>
+                <a:tc>
+                  <a:txBody>
+                    <a:bodyPr/>
+                    <a:lstStyle/>
+                    <a:p>
+                      <a:pPr indent="0" marL="0">
+                        <a:buNone/>
+                      </a:pPr>
+                      <a:r>
+                        <a:rPr lang="en-US" sz="800" dirty="0">
+                          <a:solidFill>
+                            <a:srgbClr val="58595B"/>
+                          </a:solidFill>
+                          <a:latin typeface="Calibri" pitchFamily="34" charset="0"/>
+                          <a:ea typeface="Calibri" pitchFamily="34" charset="-122"/>
+                          <a:cs typeface="Calibri" pitchFamily="34" charset="-120"/>
+                        </a:rPr>
+                        <a:t>Assistive</a:t>
+                      </a:r>
+                      <a:endParaRPr lang="en-US" sz="800" dirty="0">
+                        <a:latin typeface="Calibri" charset="0"/>
+                        <a:ea typeface="Calibri" charset="0"/>
+                        <a:cs typeface="Calibri" charset="0"/>
+                      </a:endParaRPr>
+                    </a:p>
+                  </a:txBody>
+                  <a:tcPr marL="91440" marR="91440" marT="45720" marB="45720" anchor="ctr">
+                    <a:lnL w="0" cap="flat" cmpd="sng" algn="ctr">
+                      <a:noFill/>
+                    </a:lnL>
+                    <a:lnR w="0" cap="flat" cmpd="sng" algn="ctr">
+                      <a:noFill/>
+                    </a:lnR>
+                    <a:lnT w="0" cap="flat" cmpd="sng" algn="ctr">
+                      <a:noFill/>
+                    </a:lnT>
+                    <a:lnB w="0" cap="flat" cmpd="sng" algn="ctr">
+                      <a:noFill/>
+                    </a:lnB>
+                    <a:solidFill>
+                      <a:srgbClr val="FFFFFF"/>
+                    </a:solidFill>
+                  </a:tcPr>
+                </a:tc>
+                <a:tc>
+                  <a:txBody>
+                    <a:bodyPr/>
+                    <a:lstStyle/>
+                    <a:p>
+                      <a:pPr indent="0" marL="0">
+                        <a:buNone/>
+                      </a:pPr>
+                      <a:r>
+                        <a:rPr lang="en-US" sz="800" dirty="0">
+                          <a:solidFill>
+                            <a:srgbClr val="58595B"/>
+                          </a:solidFill>
+                          <a:latin typeface="Calibri" pitchFamily="34" charset="0"/>
+                          <a:ea typeface="Calibri" pitchFamily="34" charset="-122"/>
+                          <a:cs typeface="Calibri" pitchFamily="34" charset="-120"/>
+                        </a:rPr>
+                        <a:t>AI Assistant</a:t>
+                      </a:r>
+                      <a:endParaRPr lang="en-US" sz="800" dirty="0">
+                        <a:latin typeface="Calibri" charset="0"/>
+                        <a:ea typeface="Calibri" charset="0"/>
+                        <a:cs typeface="Calibri" charset="0"/>
+                      </a:endParaRPr>
+                    </a:p>
+                  </a:txBody>
+                  <a:tcPr marL="91440" marR="91440" marT="45720" marB="45720" anchor="ctr">
+                    <a:lnL w="0" cap="flat" cmpd="sng" algn="ctr">
+                      <a:noFill/>
+                    </a:lnL>
+                    <a:lnR w="0" cap="flat" cmpd="sng" algn="ctr">
+                      <a:noFill/>
+                    </a:lnR>
+                    <a:lnT w="0" cap="flat" cmpd="sng" algn="ctr">
+                      <a:noFill/>
+                    </a:lnT>
+                    <a:lnB w="0" cap="flat" cmpd="sng" algn="ctr">
+                      <a:noFill/>
+                    </a:lnB>
+                    <a:solidFill>
+                      <a:srgbClr val="FFFFFF"/>
+                    </a:solidFill>
+                  </a:tcPr>
+                </a:tc>
+                <a:tc>
+                  <a:txBody>
+                    <a:bodyPr/>
+                    <a:lstStyle/>
+                    <a:p>
+                      <a:pPr indent="0" marL="0">
+                        <a:buNone/>
+                      </a:pPr>
+                      <a:r>
+                        <a:rPr lang="en-US" sz="800" b="1" dirty="0">
+                          <a:solidFill>
+                            <a:srgbClr val="3A3A3C"/>
+                          </a:solidFill>
+                          <a:latin typeface="Calibri" pitchFamily="34" charset="0"/>
+                          <a:ea typeface="Calibri" pitchFamily="34" charset="-122"/>
+                          <a:cs typeface="Calibri" pitchFamily="34" charset="-120"/>
+                        </a:rPr>
+                        <a:t>Production</a:t>
+                      </a:r>
+                      <a:endParaRPr lang="en-US" sz="800" dirty="0">
+                        <a:latin typeface="Calibri" charset="0"/>
+                        <a:ea typeface="Calibri" charset="0"/>
+                        <a:cs typeface="Calibri" charset="0"/>
+                      </a:endParaRPr>
+                    </a:p>
+                  </a:txBody>
+                  <a:tcPr marL="91440" marR="91440" marT="45720" marB="45720" anchor="ctr">
+                    <a:lnL w="0" cap="flat" cmpd="sng" algn="ctr">
+                      <a:noFill/>
+                    </a:lnL>
+                    <a:lnR w="0" cap="flat" cmpd="sng" algn="ctr">
+                      <a:noFill/>
+                    </a:lnR>
+                    <a:lnT w="0" cap="flat" cmpd="sng" algn="ctr">
+                      <a:noFill/>
+                    </a:lnT>
+                    <a:lnB w="0" cap="flat" cmpd="sng" algn="ctr">
+                      <a:noFill/>
+                    </a:lnB>
+                    <a:solidFill>
+                      <a:srgbClr val="FFFFFF"/>
+                    </a:solidFill>
+                  </a:tcPr>
+                </a:tc>
+                <a:tc>
+                  <a:txBody>
+                    <a:bodyPr/>
+                    <a:lstStyle/>
+                    <a:p>
+                      <a:pPr indent="0" marL="0">
+                        <a:buNone/>
+                      </a:pPr>
+                      <a:r>
+                        <a:rPr lang="en-US" sz="800" dirty="0">
+                          <a:solidFill>
+                            <a:srgbClr val="58595B"/>
+                          </a:solidFill>
+                          <a:latin typeface="Calibri" pitchFamily="34" charset="0"/>
+                          <a:ea typeface="Calibri" pitchFamily="34" charset="-122"/>
+                          <a:cs typeface="Calibri" pitchFamily="34" charset="-120"/>
+                        </a:rPr>
+                        <a:t>Answers "How do I...?" questions about NCP Solver from a built-in FAQ knowledge base.</a:t>
+                      </a:r>
+                      <a:endParaRPr lang="en-US" sz="800" dirty="0">
+                        <a:latin typeface="Calibri" charset="0"/>
+                        <a:ea typeface="Calibri" charset="0"/>
+                        <a:cs typeface="Calibri" charset="0"/>
+                      </a:endParaRPr>
+                    </a:p>
+                  </a:txBody>
+                  <a:tcPr marL="91440" marR="91440" marT="45720" marB="45720" anchor="ctr">
+                    <a:lnL w="0" cap="flat" cmpd="sng" algn="ctr">
+                      <a:noFill/>
+                    </a:lnL>
+                    <a:lnR w="0" cap="flat" cmpd="sng" algn="ctr">
+                      <a:noFill/>
+                    </a:lnR>
+                    <a:lnT w="0" cap="flat" cmpd="sng" algn="ctr">
+                      <a:noFill/>
+                    </a:lnT>
+                    <a:lnB w="0" cap="flat" cmpd="sng" algn="ctr">
+                      <a:noFill/>
+                    </a:lnB>
+                    <a:solidFill>
+                      <a:srgbClr val="FFFFFF"/>
+                    </a:solidFill>
+                  </a:tcPr>
+                </a:tc>
+              </a:tr>
+              <a:tr h="290779">
+                <a:tc>
+                  <a:txBody>
+                    <a:bodyPr/>
+                    <a:lstStyle/>
+                    <a:p>
+                      <a:pPr algn="ctr" indent="0" marL="0">
+                        <a:buNone/>
+                      </a:pPr>
+                      <a:r>
+                        <a:rPr lang="en-US" sz="800" dirty="0">
+                          <a:solidFill>
+                            <a:srgbClr val="808184"/>
+                          </a:solidFill>
+                          <a:latin typeface="Calibri" pitchFamily="34" charset="0"/>
+                          <a:ea typeface="Calibri" pitchFamily="34" charset="-122"/>
+                          <a:cs typeface="Calibri" pitchFamily="34" charset="-120"/>
+                        </a:rPr>
+                        <a:t>10</a:t>
+                      </a:r>
+                      <a:endParaRPr lang="en-US" sz="800" dirty="0">
+                        <a:latin typeface="Calibri" charset="0"/>
+                        <a:ea typeface="Calibri" charset="0"/>
+                        <a:cs typeface="Calibri" charset="0"/>
+                      </a:endParaRPr>
+                    </a:p>
+                  </a:txBody>
+                  <a:tcPr marL="91440" marR="91440" marT="45720" marB="45720" anchor="ctr">
+                    <a:lnL w="0" cap="flat" cmpd="sng" algn="ctr">
+                      <a:noFill/>
+                    </a:lnL>
+                    <a:lnR w="0" cap="flat" cmpd="sng" algn="ctr">
+                      <a:noFill/>
+                    </a:lnR>
+                    <a:lnT w="0" cap="flat" cmpd="sng" algn="ctr">
+                      <a:noFill/>
+                    </a:lnT>
+                    <a:lnB w="0" cap="flat" cmpd="sng" algn="ctr">
+                      <a:noFill/>
+                    </a:lnB>
+                    <a:solidFill>
+                      <a:srgbClr val="F2F2F3"/>
+                    </a:solidFill>
+                  </a:tcPr>
+                </a:tc>
+                <a:tc>
+                  <a:txBody>
+                    <a:bodyPr/>
+                    <a:lstStyle/>
+                    <a:p>
+                      <a:pPr indent="0" marL="0">
+                        <a:buNone/>
+                      </a:pPr>
+                      <a:r>
+                        <a:rPr lang="en-US" sz="800" b="1" dirty="0">
+                          <a:solidFill>
+                            <a:srgbClr val="3A3A3C"/>
+                          </a:solidFill>
+                          <a:latin typeface="Calibri" pitchFamily="34" charset="0"/>
+                          <a:ea typeface="Calibri" pitchFamily="34" charset="-122"/>
+                          <a:cs typeface="Calibri" pitchFamily="34" charset="-120"/>
+                        </a:rPr>
+                        <a:t>BPMN Diagram Documentation Assistant</a:t>
+                      </a:r>
+                      <a:endParaRPr lang="en-US" sz="800" dirty="0">
+                        <a:latin typeface="Calibri" charset="0"/>
+                        <a:ea typeface="Calibri" charset="0"/>
+                        <a:cs typeface="Calibri" charset="0"/>
+                      </a:endParaRPr>
+                    </a:p>
+                  </a:txBody>
+                  <a:tcPr marL="91440" marR="91440" marT="45720" marB="45720" anchor="ctr">
+                    <a:lnL w="0" cap="flat" cmpd="sng" algn="ctr">
+                      <a:noFill/>
+                    </a:lnL>
+                    <a:lnR w="0" cap="flat" cmpd="sng" algn="ctr">
+                      <a:noFill/>
+                    </a:lnR>
+                    <a:lnT w="0" cap="flat" cmpd="sng" algn="ctr">
+                      <a:noFill/>
+                    </a:lnT>
+                    <a:lnB w="0" cap="flat" cmpd="sng" algn="ctr">
+                      <a:noFill/>
+                    </a:lnB>
+                    <a:solidFill>
+                      <a:srgbClr val="F2F2F3"/>
+                    </a:solidFill>
+                  </a:tcPr>
+                </a:tc>
+                <a:tc>
+                  <a:txBody>
+                    <a:bodyPr/>
+                    <a:lstStyle/>
+                    <a:p>
+                      <a:pPr indent="0" marL="0">
+                        <a:buNone/>
+                      </a:pPr>
+                      <a:r>
+                        <a:rPr lang="en-US" sz="800" dirty="0">
+                          <a:solidFill>
+                            <a:srgbClr val="58595B"/>
+                          </a:solidFill>
+                          <a:latin typeface="Calibri" pitchFamily="34" charset="0"/>
+                          <a:ea typeface="Calibri" pitchFamily="34" charset="-122"/>
+                          <a:cs typeface="Calibri" pitchFamily="34" charset="-120"/>
+                        </a:rPr>
+                        <a:t>Assistive</a:t>
+                      </a:r>
+                      <a:endParaRPr lang="en-US" sz="800" dirty="0">
+                        <a:latin typeface="Calibri" charset="0"/>
+                        <a:ea typeface="Calibri" charset="0"/>
+                        <a:cs typeface="Calibri" charset="0"/>
+                      </a:endParaRPr>
+                    </a:p>
+                  </a:txBody>
+                  <a:tcPr marL="91440" marR="91440" marT="45720" marB="45720" anchor="ctr">
+                    <a:lnL w="0" cap="flat" cmpd="sng" algn="ctr">
+                      <a:noFill/>
+                    </a:lnL>
+                    <a:lnR w="0" cap="flat" cmpd="sng" algn="ctr">
+                      <a:noFill/>
+                    </a:lnR>
+                    <a:lnT w="0" cap="flat" cmpd="sng" algn="ctr">
+                      <a:noFill/>
+                    </a:lnT>
+                    <a:lnB w="0" cap="flat" cmpd="sng" algn="ctr">
+                      <a:noFill/>
+                    </a:lnB>
+                    <a:solidFill>
+                      <a:srgbClr val="F2F2F3"/>
+                    </a:solidFill>
+                  </a:tcPr>
+                </a:tc>
+                <a:tc>
+                  <a:txBody>
+                    <a:bodyPr/>
+                    <a:lstStyle/>
+                    <a:p>
+                      <a:pPr indent="0" marL="0">
+                        <a:buNone/>
+                      </a:pPr>
+                      <a:r>
+                        <a:rPr lang="en-US" sz="800" dirty="0">
+                          <a:solidFill>
+                            <a:srgbClr val="58595B"/>
+                          </a:solidFill>
+                          <a:latin typeface="Calibri" pitchFamily="34" charset="0"/>
+                          <a:ea typeface="Calibri" pitchFamily="34" charset="-122"/>
+                          <a:cs typeface="Calibri" pitchFamily="34" charset="-120"/>
+                        </a:rPr>
+                        <a:t>BPMN</a:t>
+                      </a:r>
+                      <a:endParaRPr lang="en-US" sz="800" dirty="0">
+                        <a:latin typeface="Calibri" charset="0"/>
+                        <a:ea typeface="Calibri" charset="0"/>
+                        <a:cs typeface="Calibri" charset="0"/>
+                      </a:endParaRPr>
+                    </a:p>
+                  </a:txBody>
+                  <a:tcPr marL="91440" marR="91440" marT="45720" marB="45720" anchor="ctr">
+                    <a:lnL w="0" cap="flat" cmpd="sng" algn="ctr">
+                      <a:noFill/>
+                    </a:lnL>
+                    <a:lnR w="0" cap="flat" cmpd="sng" algn="ctr">
+                      <a:noFill/>
+                    </a:lnR>
+                    <a:lnT w="0" cap="flat" cmpd="sng" algn="ctr">
+                      <a:noFill/>
+                    </a:lnT>
+                    <a:lnB w="0" cap="flat" cmpd="sng" algn="ctr">
+                      <a:noFill/>
+                    </a:lnB>
+                    <a:solidFill>
+                      <a:srgbClr val="F2F2F3"/>
+                    </a:solidFill>
+                  </a:tcPr>
+                </a:tc>
+                <a:tc>
+                  <a:txBody>
+                    <a:bodyPr/>
+                    <a:lstStyle/>
+                    <a:p>
+                      <a:pPr indent="0" marL="0">
+                        <a:buNone/>
+                      </a:pPr>
+                      <a:r>
+                        <a:rPr lang="en-US" sz="800" i="1" dirty="0">
+                          <a:solidFill>
+                            <a:srgbClr val="808184"/>
+                          </a:solidFill>
+                          <a:latin typeface="Calibri" pitchFamily="34" charset="0"/>
+                          <a:ea typeface="Calibri" pitchFamily="34" charset="-122"/>
+                          <a:cs typeface="Calibri" pitchFamily="34" charset="-120"/>
+                        </a:rPr>
+                        <a:t>Roadmap</a:t>
+                      </a:r>
+                      <a:endParaRPr lang="en-US" sz="800" dirty="0">
+                        <a:latin typeface="Calibri" charset="0"/>
+                        <a:ea typeface="Calibri" charset="0"/>
+                        <a:cs typeface="Calibri" charset="0"/>
+                      </a:endParaRPr>
+                    </a:p>
+                  </a:txBody>
+                  <a:tcPr marL="91440" marR="91440" marT="45720" marB="45720" anchor="ctr">
+                    <a:lnL w="0" cap="flat" cmpd="sng" algn="ctr">
+                      <a:noFill/>
+                    </a:lnL>
+                    <a:lnR w="0" cap="flat" cmpd="sng" algn="ctr">
+                      <a:noFill/>
+                    </a:lnR>
+                    <a:lnT w="0" cap="flat" cmpd="sng" algn="ctr">
+                      <a:noFill/>
+                    </a:lnT>
+                    <a:lnB w="0" cap="flat" cmpd="sng" algn="ctr">
+                      <a:noFill/>
+                    </a:lnB>
+                    <a:solidFill>
+                      <a:srgbClr val="F2F2F3"/>
+                    </a:solidFill>
+                  </a:tcPr>
+                </a:tc>
+                <a:tc>
+                  <a:txBody>
+                    <a:bodyPr/>
+                    <a:lstStyle/>
+                    <a:p>
+                      <a:pPr indent="0" marL="0">
+                        <a:buNone/>
+                      </a:pPr>
+                      <a:r>
+                        <a:rPr lang="en-US" sz="800" dirty="0">
+                          <a:solidFill>
+                            <a:srgbClr val="58595B"/>
+                          </a:solidFill>
+                          <a:latin typeface="Calibri" pitchFamily="34" charset="0"/>
+                          <a:ea typeface="Calibri" pitchFamily="34" charset="-122"/>
+                          <a:cs typeface="Calibri" pitchFamily="34" charset="-120"/>
+                        </a:rPr>
+                        <a:t>Generates a plain-language walkthrough of a BPMN diagram's flow, gateways, and loops.</a:t>
+                      </a:r>
+                      <a:endParaRPr lang="en-US" sz="800" dirty="0">
+                        <a:latin typeface="Calibri" charset="0"/>
+                        <a:ea typeface="Calibri" charset="0"/>
+                        <a:cs typeface="Calibri" charset="0"/>
+                      </a:endParaRPr>
+                    </a:p>
+                  </a:txBody>
+                  <a:tcPr marL="91440" marR="91440" marT="45720" marB="45720" anchor="ctr">
+                    <a:lnL w="0" cap="flat" cmpd="sng" algn="ctr">
+                      <a:noFill/>
+                    </a:lnL>
+                    <a:lnR w="0" cap="flat" cmpd="sng" algn="ctr">
+                      <a:noFill/>
+                    </a:lnR>
+                    <a:lnT w="0" cap="flat" cmpd="sng" algn="ctr">
+                      <a:noFill/>
+                    </a:lnT>
+                    <a:lnB w="0" cap="flat" cmpd="sng" algn="ctr">
+                      <a:noFill/>
+                    </a:lnB>
+                    <a:solidFill>
+                      <a:srgbClr val="F2F2F3"/>
+                    </a:solidFill>
+                  </a:tcPr>
+                </a:tc>
+              </a:tr>
+              <a:tr h="290779">
+                <a:tc>
+                  <a:txBody>
+                    <a:bodyPr/>
+                    <a:lstStyle/>
+                    <a:p>
+                      <a:pPr algn="ctr" indent="0" marL="0">
+                        <a:buNone/>
+                      </a:pPr>
+                      <a:r>
+                        <a:rPr lang="en-US" sz="800" dirty="0">
+                          <a:solidFill>
+                            <a:srgbClr val="808184"/>
+                          </a:solidFill>
+                          <a:latin typeface="Calibri" pitchFamily="34" charset="0"/>
+                          <a:ea typeface="Calibri" pitchFamily="34" charset="-122"/>
+                          <a:cs typeface="Calibri" pitchFamily="34" charset="-120"/>
+                        </a:rPr>
+                        <a:t>11</a:t>
+                      </a:r>
+                      <a:endParaRPr lang="en-US" sz="800" dirty="0">
+                        <a:latin typeface="Calibri" charset="0"/>
+                        <a:ea typeface="Calibri" charset="0"/>
+                        <a:cs typeface="Calibri" charset="0"/>
+                      </a:endParaRPr>
+                    </a:p>
+                  </a:txBody>
+                  <a:tcPr marL="91440" marR="91440" marT="45720" marB="45720" anchor="ctr">
+                    <a:lnL w="0" cap="flat" cmpd="sng" algn="ctr">
+                      <a:noFill/>
+                    </a:lnL>
+                    <a:lnR w="0" cap="flat" cmpd="sng" algn="ctr">
+                      <a:noFill/>
+                    </a:lnR>
+                    <a:lnT w="0" cap="flat" cmpd="sng" algn="ctr">
+                      <a:noFill/>
+                    </a:lnT>
+                    <a:lnB w="0" cap="flat" cmpd="sng" algn="ctr">
+                      <a:noFill/>
+                    </a:lnB>
+                    <a:solidFill>
+                      <a:srgbClr val="FFFFFF"/>
+                    </a:solidFill>
+                  </a:tcPr>
+                </a:tc>
+                <a:tc>
+                  <a:txBody>
+                    <a:bodyPr/>
+                    <a:lstStyle/>
+                    <a:p>
+                      <a:pPr indent="0" marL="0">
+                        <a:buNone/>
+                      </a:pPr>
+                      <a:r>
+                        <a:rPr lang="en-US" sz="800" b="1" dirty="0">
+                          <a:solidFill>
+                            <a:srgbClr val="3A3A3C"/>
+                          </a:solidFill>
+                          <a:latin typeface="Calibri" pitchFamily="34" charset="0"/>
+                          <a:ea typeface="Calibri" pitchFamily="34" charset="-122"/>
+                          <a:cs typeface="Calibri" pitchFamily="34" charset="-120"/>
+                        </a:rPr>
+                        <a:t>Risk Narrative &amp; Mitigation Drafting Assistant</a:t>
+                      </a:r>
+                      <a:endParaRPr lang="en-US" sz="800" dirty="0">
+                        <a:latin typeface="Calibri" charset="0"/>
+                        <a:ea typeface="Calibri" charset="0"/>
+                        <a:cs typeface="Calibri" charset="0"/>
+                      </a:endParaRPr>
+                    </a:p>
+                  </a:txBody>
+                  <a:tcPr marL="91440" marR="91440" marT="45720" marB="45720" anchor="ctr">
+                    <a:lnL w="0" cap="flat" cmpd="sng" algn="ctr">
+                      <a:noFill/>
+                    </a:lnL>
+                    <a:lnR w="0" cap="flat" cmpd="sng" algn="ctr">
+                      <a:noFill/>
+                    </a:lnR>
+                    <a:lnT w="0" cap="flat" cmpd="sng" algn="ctr">
+                      <a:noFill/>
+                    </a:lnT>
+                    <a:lnB w="0" cap="flat" cmpd="sng" algn="ctr">
+                      <a:noFill/>
+                    </a:lnB>
+                    <a:solidFill>
+                      <a:srgbClr val="FFFFFF"/>
+                    </a:solidFill>
+                  </a:tcPr>
+                </a:tc>
+                <a:tc>
+                  <a:txBody>
+                    <a:bodyPr/>
+                    <a:lstStyle/>
+                    <a:p>
+                      <a:pPr indent="0" marL="0">
+                        <a:buNone/>
+                      </a:pPr>
+                      <a:r>
+                        <a:rPr lang="en-US" sz="800" b="1" dirty="0">
+                          <a:solidFill>
+                            <a:srgbClr val="E07B00"/>
+                          </a:solidFill>
+                          <a:latin typeface="Calibri" pitchFamily="34" charset="0"/>
+                          <a:ea typeface="Calibri" pitchFamily="34" charset="-122"/>
+                          <a:cs typeface="Calibri" pitchFamily="34" charset="-120"/>
+                        </a:rPr>
+                        <a:t>Augmented</a:t>
+                      </a:r>
+                      <a:endParaRPr lang="en-US" sz="800" dirty="0">
+                        <a:latin typeface="Calibri" charset="0"/>
+                        <a:ea typeface="Calibri" charset="0"/>
+                        <a:cs typeface="Calibri" charset="0"/>
+                      </a:endParaRPr>
+                    </a:p>
+                  </a:txBody>
+                  <a:tcPr marL="91440" marR="91440" marT="45720" marB="45720" anchor="ctr">
+                    <a:lnL w="0" cap="flat" cmpd="sng" algn="ctr">
+                      <a:noFill/>
+                    </a:lnL>
+                    <a:lnR w="0" cap="flat" cmpd="sng" algn="ctr">
+                      <a:noFill/>
+                    </a:lnR>
+                    <a:lnT w="0" cap="flat" cmpd="sng" algn="ctr">
+                      <a:noFill/>
+                    </a:lnT>
+                    <a:lnB w="0" cap="flat" cmpd="sng" algn="ctr">
+                      <a:noFill/>
+                    </a:lnB>
+                    <a:solidFill>
+                      <a:srgbClr val="FFFFFF"/>
+                    </a:solidFill>
+                  </a:tcPr>
+                </a:tc>
+                <a:tc>
+                  <a:txBody>
+                    <a:bodyPr/>
+                    <a:lstStyle/>
+                    <a:p>
+                      <a:pPr indent="0" marL="0">
+                        <a:buNone/>
+                      </a:pPr>
+                      <a:r>
+                        <a:rPr lang="en-US" sz="800" dirty="0">
+                          <a:solidFill>
+                            <a:srgbClr val="58595B"/>
+                          </a:solidFill>
+                          <a:latin typeface="Calibri" pitchFamily="34" charset="0"/>
+                          <a:ea typeface="Calibri" pitchFamily="34" charset="-122"/>
+                          <a:cs typeface="Calibri" pitchFamily="34" charset="-120"/>
+                        </a:rPr>
+                        <a:t>Risk &amp; Opp.</a:t>
+                      </a:r>
+                      <a:endParaRPr lang="en-US" sz="800" dirty="0">
+                        <a:latin typeface="Calibri" charset="0"/>
+                        <a:ea typeface="Calibri" charset="0"/>
+                        <a:cs typeface="Calibri" charset="0"/>
+                      </a:endParaRPr>
+                    </a:p>
+                  </a:txBody>
+                  <a:tcPr marL="91440" marR="91440" marT="45720" marB="45720" anchor="ctr">
+                    <a:lnL w="0" cap="flat" cmpd="sng" algn="ctr">
+                      <a:noFill/>
+                    </a:lnL>
+                    <a:lnR w="0" cap="flat" cmpd="sng" algn="ctr">
+                      <a:noFill/>
+                    </a:lnR>
+                    <a:lnT w="0" cap="flat" cmpd="sng" algn="ctr">
+                      <a:noFill/>
+                    </a:lnT>
+                    <a:lnB w="0" cap="flat" cmpd="sng" algn="ctr">
+                      <a:noFill/>
+                    </a:lnB>
+                    <a:solidFill>
+                      <a:srgbClr val="FFFFFF"/>
+                    </a:solidFill>
+                  </a:tcPr>
+                </a:tc>
+                <a:tc>
+                  <a:txBody>
+                    <a:bodyPr/>
+                    <a:lstStyle/>
+                    <a:p>
+                      <a:pPr indent="0" marL="0">
+                        <a:buNone/>
+                      </a:pPr>
+                      <a:r>
+                        <a:rPr lang="en-US" sz="800" i="1" dirty="0">
+                          <a:solidFill>
+                            <a:srgbClr val="808184"/>
+                          </a:solidFill>
+                          <a:latin typeface="Calibri" pitchFamily="34" charset="0"/>
+                          <a:ea typeface="Calibri" pitchFamily="34" charset="-122"/>
+                          <a:cs typeface="Calibri" pitchFamily="34" charset="-120"/>
+                        </a:rPr>
+                        <a:t>Roadmap</a:t>
+                      </a:r>
+                      <a:endParaRPr lang="en-US" sz="800" dirty="0">
+                        <a:latin typeface="Calibri" charset="0"/>
+                        <a:ea typeface="Calibri" charset="0"/>
+                        <a:cs typeface="Calibri" charset="0"/>
+                      </a:endParaRPr>
+                    </a:p>
+                  </a:txBody>
+                  <a:tcPr marL="91440" marR="91440" marT="45720" marB="45720" anchor="ctr">
+                    <a:lnL w="0" cap="flat" cmpd="sng" algn="ctr">
+                      <a:noFill/>
+                    </a:lnL>
+                    <a:lnR w="0" cap="flat" cmpd="sng" algn="ctr">
+                      <a:noFill/>
+                    </a:lnR>
+                    <a:lnT w="0" cap="flat" cmpd="sng" algn="ctr">
+                      <a:noFill/>
+                    </a:lnT>
+                    <a:lnB w="0" cap="flat" cmpd="sng" algn="ctr">
+                      <a:noFill/>
+                    </a:lnB>
+                    <a:solidFill>
+                      <a:srgbClr val="FFFFFF"/>
+                    </a:solidFill>
+                  </a:tcPr>
+                </a:tc>
+                <a:tc>
+                  <a:txBody>
+                    <a:bodyPr/>
+                    <a:lstStyle/>
+                    <a:p>
+                      <a:pPr indent="0" marL="0">
+                        <a:buNone/>
+                      </a:pPr>
+                      <a:r>
+                        <a:rPr lang="en-US" sz="800" dirty="0">
+                          <a:solidFill>
+                            <a:srgbClr val="58595B"/>
+                          </a:solidFill>
+                          <a:latin typeface="Calibri" pitchFamily="34" charset="0"/>
+                          <a:ea typeface="Calibri" pitchFamily="34" charset="-122"/>
+                          <a:cs typeface="Calibri" pitchFamily="34" charset="-120"/>
+                        </a:rPr>
+                        <a:t>Drafts a description, causes, and mitigation plan for a new Risk/Opportunity item.</a:t>
+                      </a:r>
+                      <a:endParaRPr lang="en-US" sz="800" dirty="0">
+                        <a:latin typeface="Calibri" charset="0"/>
+                        <a:ea typeface="Calibri" charset="0"/>
+                        <a:cs typeface="Calibri" charset="0"/>
+                      </a:endParaRPr>
+                    </a:p>
+                  </a:txBody>
+                  <a:tcPr marL="91440" marR="91440" marT="45720" marB="45720" anchor="ctr">
+                    <a:lnL w="0" cap="flat" cmpd="sng" algn="ctr">
+                      <a:noFill/>
+                    </a:lnL>
+                    <a:lnR w="0" cap="flat" cmpd="sng" algn="ctr">
+                      <a:noFill/>
+                    </a:lnR>
+                    <a:lnT w="0" cap="flat" cmpd="sng" algn="ctr">
+                      <a:noFill/>
+                    </a:lnT>
+                    <a:lnB w="0" cap="flat" cmpd="sng" algn="ctr">
+                      <a:noFill/>
+                    </a:lnB>
+                    <a:solidFill>
+                      <a:srgbClr val="FFFFFF"/>
+                    </a:solidFill>
+                  </a:tcPr>
+                </a:tc>
+              </a:tr>
+              <a:tr h="290779">
+                <a:tc>
+                  <a:txBody>
+                    <a:bodyPr/>
+                    <a:lstStyle/>
+                    <a:p>
+                      <a:pPr algn="ctr" indent="0" marL="0">
+                        <a:buNone/>
+                      </a:pPr>
+                      <a:r>
+                        <a:rPr lang="en-US" sz="800" dirty="0">
+                          <a:solidFill>
+                            <a:srgbClr val="808184"/>
+                          </a:solidFill>
+                          <a:latin typeface="Calibri" pitchFamily="34" charset="0"/>
+                          <a:ea typeface="Calibri" pitchFamily="34" charset="-122"/>
+                          <a:cs typeface="Calibri" pitchFamily="34" charset="-120"/>
+                        </a:rPr>
+                        <a:t>12</a:t>
+                      </a:r>
+                      <a:endParaRPr lang="en-US" sz="800" dirty="0">
+                        <a:latin typeface="Calibri" charset="0"/>
+                        <a:ea typeface="Calibri" charset="0"/>
+                        <a:cs typeface="Calibri" charset="0"/>
+                      </a:endParaRPr>
+                    </a:p>
+                  </a:txBody>
+                  <a:tcPr marL="91440" marR="91440" marT="45720" marB="45720" anchor="ctr">
+                    <a:lnL w="0" cap="flat" cmpd="sng" algn="ctr">
+                      <a:noFill/>
+                    </a:lnL>
+                    <a:lnR w="0" cap="flat" cmpd="sng" algn="ctr">
+                      <a:noFill/>
+                    </a:lnR>
+                    <a:lnT w="0" cap="flat" cmpd="sng" algn="ctr">
+                      <a:noFill/>
+                    </a:lnT>
+                    <a:lnB w="0" cap="flat" cmpd="sng" algn="ctr">
+                      <a:noFill/>
+                    </a:lnB>
+                    <a:solidFill>
+                      <a:srgbClr val="F2F2F3"/>
+                    </a:solidFill>
+                  </a:tcPr>
+                </a:tc>
+                <a:tc>
+                  <a:txBody>
+                    <a:bodyPr/>
+                    <a:lstStyle/>
+                    <a:p>
+                      <a:pPr indent="0" marL="0">
+                        <a:buNone/>
+                      </a:pPr>
+                      <a:r>
+                        <a:rPr lang="en-US" sz="800" b="1" dirty="0">
+                          <a:solidFill>
+                            <a:srgbClr val="3A3A3C"/>
+                          </a:solidFill>
+                          <a:latin typeface="Calibri" pitchFamily="34" charset="0"/>
+                          <a:ea typeface="Calibri" pitchFamily="34" charset="-122"/>
+                          <a:cs typeface="Calibri" pitchFamily="34" charset="-120"/>
+                        </a:rPr>
+                        <a:t>Control Test Summary Assistant</a:t>
+                      </a:r>
+                      <a:endParaRPr lang="en-US" sz="800" dirty="0">
+                        <a:latin typeface="Calibri" charset="0"/>
+                        <a:ea typeface="Calibri" charset="0"/>
+                        <a:cs typeface="Calibri" charset="0"/>
+                      </a:endParaRPr>
+                    </a:p>
+                  </a:txBody>
+                  <a:tcPr marL="91440" marR="91440" marT="45720" marB="45720" anchor="ctr">
+                    <a:lnL w="0" cap="flat" cmpd="sng" algn="ctr">
+                      <a:noFill/>
+                    </a:lnL>
+                    <a:lnR w="0" cap="flat" cmpd="sng" algn="ctr">
+                      <a:noFill/>
+                    </a:lnR>
+                    <a:lnT w="0" cap="flat" cmpd="sng" algn="ctr">
+                      <a:noFill/>
+                    </a:lnT>
+                    <a:lnB w="0" cap="flat" cmpd="sng" algn="ctr">
+                      <a:noFill/>
+                    </a:lnB>
+                    <a:solidFill>
+                      <a:srgbClr val="F2F2F3"/>
+                    </a:solidFill>
+                  </a:tcPr>
+                </a:tc>
+                <a:tc>
+                  <a:txBody>
+                    <a:bodyPr/>
+                    <a:lstStyle/>
+                    <a:p>
+                      <a:pPr indent="0" marL="0">
+                        <a:buNone/>
+                      </a:pPr>
+                      <a:r>
+                        <a:rPr lang="en-US" sz="800" dirty="0">
+                          <a:solidFill>
+                            <a:srgbClr val="58595B"/>
+                          </a:solidFill>
+                          <a:latin typeface="Calibri" pitchFamily="34" charset="0"/>
+                          <a:ea typeface="Calibri" pitchFamily="34" charset="-122"/>
+                          <a:cs typeface="Calibri" pitchFamily="34" charset="-120"/>
+                        </a:rPr>
+                        <a:t>Assistive</a:t>
+                      </a:r>
+                      <a:endParaRPr lang="en-US" sz="800" dirty="0">
+                        <a:latin typeface="Calibri" charset="0"/>
+                        <a:ea typeface="Calibri" charset="0"/>
+                        <a:cs typeface="Calibri" charset="0"/>
+                      </a:endParaRPr>
+                    </a:p>
+                  </a:txBody>
+                  <a:tcPr marL="91440" marR="91440" marT="45720" marB="45720" anchor="ctr">
+                    <a:lnL w="0" cap="flat" cmpd="sng" algn="ctr">
+                      <a:noFill/>
+                    </a:lnL>
+                    <a:lnR w="0" cap="flat" cmpd="sng" algn="ctr">
+                      <a:noFill/>
+                    </a:lnR>
+                    <a:lnT w="0" cap="flat" cmpd="sng" algn="ctr">
+                      <a:noFill/>
+                    </a:lnT>
+                    <a:lnB w="0" cap="flat" cmpd="sng" algn="ctr">
+                      <a:noFill/>
+                    </a:lnB>
+                    <a:solidFill>
+                      <a:srgbClr val="F2F2F3"/>
+                    </a:solidFill>
+                  </a:tcPr>
+                </a:tc>
+                <a:tc>
+                  <a:txBody>
+                    <a:bodyPr/>
+                    <a:lstStyle/>
+                    <a:p>
+                      <a:pPr indent="0" marL="0">
+                        <a:buNone/>
+                      </a:pPr>
+                      <a:r>
+                        <a:rPr lang="en-US" sz="800" dirty="0">
+                          <a:solidFill>
+                            <a:srgbClr val="58595B"/>
+                          </a:solidFill>
+                          <a:latin typeface="Calibri" pitchFamily="34" charset="0"/>
+                          <a:ea typeface="Calibri" pitchFamily="34" charset="-122"/>
+                          <a:cs typeface="Calibri" pitchFamily="34" charset="-120"/>
+                        </a:rPr>
+                        <a:t>Control</a:t>
+                      </a:r>
+                      <a:endParaRPr lang="en-US" sz="800" dirty="0">
+                        <a:latin typeface="Calibri" charset="0"/>
+                        <a:ea typeface="Calibri" charset="0"/>
+                        <a:cs typeface="Calibri" charset="0"/>
+                      </a:endParaRPr>
+                    </a:p>
+                  </a:txBody>
+                  <a:tcPr marL="91440" marR="91440" marT="45720" marB="45720" anchor="ctr">
+                    <a:lnL w="0" cap="flat" cmpd="sng" algn="ctr">
+                      <a:noFill/>
+                    </a:lnL>
+                    <a:lnR w="0" cap="flat" cmpd="sng" algn="ctr">
+                      <a:noFill/>
+                    </a:lnR>
+                    <a:lnT w="0" cap="flat" cmpd="sng" algn="ctr">
+                      <a:noFill/>
+                    </a:lnT>
+                    <a:lnB w="0" cap="flat" cmpd="sng" algn="ctr">
+                      <a:noFill/>
+                    </a:lnB>
+                    <a:solidFill>
+                      <a:srgbClr val="F2F2F3"/>
+                    </a:solidFill>
+                  </a:tcPr>
+                </a:tc>
+                <a:tc>
+                  <a:txBody>
+                    <a:bodyPr/>
+                    <a:lstStyle/>
+                    <a:p>
+                      <a:pPr indent="0" marL="0">
+                        <a:buNone/>
+                      </a:pPr>
+                      <a:r>
+                        <a:rPr lang="en-US" sz="800" i="1" dirty="0">
+                          <a:solidFill>
+                            <a:srgbClr val="808184"/>
+                          </a:solidFill>
+                          <a:latin typeface="Calibri" pitchFamily="34" charset="0"/>
+                          <a:ea typeface="Calibri" pitchFamily="34" charset="-122"/>
+                          <a:cs typeface="Calibri" pitchFamily="34" charset="-120"/>
+                        </a:rPr>
+                        <a:t>Roadmap</a:t>
+                      </a:r>
+                      <a:endParaRPr lang="en-US" sz="800" dirty="0">
+                        <a:latin typeface="Calibri" charset="0"/>
+                        <a:ea typeface="Calibri" charset="0"/>
+                        <a:cs typeface="Calibri" charset="0"/>
+                      </a:endParaRPr>
+                    </a:p>
+                  </a:txBody>
+                  <a:tcPr marL="91440" marR="91440" marT="45720" marB="45720" anchor="ctr">
+                    <a:lnL w="0" cap="flat" cmpd="sng" algn="ctr">
+                      <a:noFill/>
+                    </a:lnL>
+                    <a:lnR w="0" cap="flat" cmpd="sng" algn="ctr">
+                      <a:noFill/>
+                    </a:lnR>
+                    <a:lnT w="0" cap="flat" cmpd="sng" algn="ctr">
+                      <a:noFill/>
+                    </a:lnT>
+                    <a:lnB w="0" cap="flat" cmpd="sng" algn="ctr">
+                      <a:noFill/>
+                    </a:lnB>
+                    <a:solidFill>
+                      <a:srgbClr val="F2F2F3"/>
+                    </a:solidFill>
+                  </a:tcPr>
+                </a:tc>
+                <a:tc>
+                  <a:txBody>
+                    <a:bodyPr/>
+                    <a:lstStyle/>
+                    <a:p>
+                      <a:pPr indent="0" marL="0">
+                        <a:buNone/>
+                      </a:pPr>
+                      <a:r>
+                        <a:rPr lang="en-US" sz="800" dirty="0">
+                          <a:solidFill>
+                            <a:srgbClr val="58595B"/>
+                          </a:solidFill>
+                          <a:latin typeface="Calibri" pitchFamily="34" charset="0"/>
+                          <a:ea typeface="Calibri" pitchFamily="34" charset="-122"/>
+                          <a:cs typeface="Calibri" pitchFamily="34" charset="-120"/>
+                        </a:rPr>
+                        <a:t>Summarizes a Control's test history and effectiveness trend in one paragraph.</a:t>
+                      </a:r>
+                      <a:endParaRPr lang="en-US" sz="800" dirty="0">
+                        <a:latin typeface="Calibri" charset="0"/>
+                        <a:ea typeface="Calibri" charset="0"/>
+                        <a:cs typeface="Calibri" charset="0"/>
+                      </a:endParaRPr>
+                    </a:p>
+                  </a:txBody>
+                  <a:tcPr marL="91440" marR="91440" marT="45720" marB="45720" anchor="ctr">
+                    <a:lnL w="0" cap="flat" cmpd="sng" algn="ctr">
+                      <a:noFill/>
+                    </a:lnL>
+                    <a:lnR w="0" cap="flat" cmpd="sng" algn="ctr">
+                      <a:noFill/>
+                    </a:lnR>
+                    <a:lnT w="0" cap="flat" cmpd="sng" algn="ctr">
+                      <a:noFill/>
+                    </a:lnT>
+                    <a:lnB w="0" cap="flat" cmpd="sng" algn="ctr">
+                      <a:noFill/>
+                    </a:lnB>
+                    <a:solidFill>
+                      <a:srgbClr val="F2F2F3"/>
+                    </a:solidFill>
+                  </a:tcPr>
+                </a:tc>
+              </a:tr>
+              <a:tr h="290779">
+                <a:tc>
+                  <a:txBody>
+                    <a:bodyPr/>
+                    <a:lstStyle/>
+                    <a:p>
+                      <a:pPr algn="ctr" indent="0" marL="0">
+                        <a:buNone/>
+                      </a:pPr>
+                      <a:r>
+                        <a:rPr lang="en-US" sz="800" dirty="0">
+                          <a:solidFill>
+                            <a:srgbClr val="808184"/>
+                          </a:solidFill>
+                          <a:latin typeface="Calibri" pitchFamily="34" charset="0"/>
+                          <a:ea typeface="Calibri" pitchFamily="34" charset="-122"/>
+                          <a:cs typeface="Calibri" pitchFamily="34" charset="-120"/>
+                        </a:rPr>
+                        <a:t>13</a:t>
+                      </a:r>
+                      <a:endParaRPr lang="en-US" sz="800" dirty="0">
+                        <a:latin typeface="Calibri" charset="0"/>
+                        <a:ea typeface="Calibri" charset="0"/>
+                        <a:cs typeface="Calibri" charset="0"/>
+                      </a:endParaRPr>
+                    </a:p>
+                  </a:txBody>
+                  <a:tcPr marL="91440" marR="91440" marT="45720" marB="45720" anchor="ctr">
+                    <a:lnL w="0" cap="flat" cmpd="sng" algn="ctr">
+                      <a:noFill/>
+                    </a:lnL>
+                    <a:lnR w="0" cap="flat" cmpd="sng" algn="ctr">
+                      <a:noFill/>
+                    </a:lnR>
+                    <a:lnT w="0" cap="flat" cmpd="sng" algn="ctr">
+                      <a:noFill/>
+                    </a:lnT>
+                    <a:lnB w="0" cap="flat" cmpd="sng" algn="ctr">
+                      <a:noFill/>
+                    </a:lnB>
+                    <a:solidFill>
+                      <a:srgbClr val="FFFFFF"/>
+                    </a:solidFill>
+                  </a:tcPr>
+                </a:tc>
+                <a:tc>
+                  <a:txBody>
+                    <a:bodyPr/>
+                    <a:lstStyle/>
+                    <a:p>
+                      <a:pPr indent="0" marL="0">
+                        <a:buNone/>
+                      </a:pPr>
+                      <a:r>
+                        <a:rPr lang="en-US" sz="800" b="1" dirty="0">
+                          <a:solidFill>
+                            <a:srgbClr val="3A3A3C"/>
+                          </a:solidFill>
+                          <a:latin typeface="Calibri" pitchFamily="34" charset="0"/>
+                          <a:ea typeface="Calibri" pitchFamily="34" charset="-122"/>
+                          <a:cs typeface="Calibri" pitchFamily="34" charset="-120"/>
+                        </a:rPr>
+                        <a:t>Business Rule Drafting Assistant</a:t>
+                      </a:r>
+                      <a:endParaRPr lang="en-US" sz="800" dirty="0">
+                        <a:latin typeface="Calibri" charset="0"/>
+                        <a:ea typeface="Calibri" charset="0"/>
+                        <a:cs typeface="Calibri" charset="0"/>
+                      </a:endParaRPr>
+                    </a:p>
+                  </a:txBody>
+                  <a:tcPr marL="91440" marR="91440" marT="45720" marB="45720" anchor="ctr">
+                    <a:lnL w="0" cap="flat" cmpd="sng" algn="ctr">
+                      <a:noFill/>
+                    </a:lnL>
+                    <a:lnR w="0" cap="flat" cmpd="sng" algn="ctr">
+                      <a:noFill/>
+                    </a:lnR>
+                    <a:lnT w="0" cap="flat" cmpd="sng" algn="ctr">
+                      <a:noFill/>
+                    </a:lnT>
+                    <a:lnB w="0" cap="flat" cmpd="sng" algn="ctr">
+                      <a:noFill/>
+                    </a:lnB>
+                    <a:solidFill>
+                      <a:srgbClr val="FFFFFF"/>
+                    </a:solidFill>
+                  </a:tcPr>
+                </a:tc>
+                <a:tc>
+                  <a:txBody>
+                    <a:bodyPr/>
+                    <a:lstStyle/>
+                    <a:p>
+                      <a:pPr indent="0" marL="0">
+                        <a:buNone/>
+                      </a:pPr>
+                      <a:r>
+                        <a:rPr lang="en-US" sz="800" b="1" dirty="0">
+                          <a:solidFill>
+                            <a:srgbClr val="E07B00"/>
+                          </a:solidFill>
+                          <a:latin typeface="Calibri" pitchFamily="34" charset="0"/>
+                          <a:ea typeface="Calibri" pitchFamily="34" charset="-122"/>
+                          <a:cs typeface="Calibri" pitchFamily="34" charset="-120"/>
+                        </a:rPr>
+                        <a:t>Augmented</a:t>
+                      </a:r>
+                      <a:endParaRPr lang="en-US" sz="800" dirty="0">
+                        <a:latin typeface="Calibri" charset="0"/>
+                        <a:ea typeface="Calibri" charset="0"/>
+                        <a:cs typeface="Calibri" charset="0"/>
+                      </a:endParaRPr>
+                    </a:p>
+                  </a:txBody>
+                  <a:tcPr marL="91440" marR="91440" marT="45720" marB="45720" anchor="ctr">
+                    <a:lnL w="0" cap="flat" cmpd="sng" algn="ctr">
+                      <a:noFill/>
+                    </a:lnL>
+                    <a:lnR w="0" cap="flat" cmpd="sng" algn="ctr">
+                      <a:noFill/>
+                    </a:lnR>
+                    <a:lnT w="0" cap="flat" cmpd="sng" algn="ctr">
+                      <a:noFill/>
+                    </a:lnT>
+                    <a:lnB w="0" cap="flat" cmpd="sng" algn="ctr">
+                      <a:noFill/>
+                    </a:lnB>
+                    <a:solidFill>
+                      <a:srgbClr val="FFFFFF"/>
+                    </a:solidFill>
+                  </a:tcPr>
+                </a:tc>
+                <a:tc>
+                  <a:txBody>
+                    <a:bodyPr/>
+                    <a:lstStyle/>
+                    <a:p>
+                      <a:pPr indent="0" marL="0">
+                        <a:buNone/>
+                      </a:pPr>
+                      <a:r>
+                        <a:rPr lang="en-US" sz="800" dirty="0">
+                          <a:solidFill>
+                            <a:srgbClr val="58595B"/>
+                          </a:solidFill>
+                          <a:latin typeface="Calibri" pitchFamily="34" charset="0"/>
+                          <a:ea typeface="Calibri" pitchFamily="34" charset="-122"/>
+                          <a:cs typeface="Calibri" pitchFamily="34" charset="-120"/>
+                        </a:rPr>
+                        <a:t>Business Rule</a:t>
+                      </a:r>
+                      <a:endParaRPr lang="en-US" sz="800" dirty="0">
+                        <a:latin typeface="Calibri" charset="0"/>
+                        <a:ea typeface="Calibri" charset="0"/>
+                        <a:cs typeface="Calibri" charset="0"/>
+                      </a:endParaRPr>
+                    </a:p>
+                  </a:txBody>
+                  <a:tcPr marL="91440" marR="91440" marT="45720" marB="45720" anchor="ctr">
+                    <a:lnL w="0" cap="flat" cmpd="sng" algn="ctr">
+                      <a:noFill/>
+                    </a:lnL>
+                    <a:lnR w="0" cap="flat" cmpd="sng" algn="ctr">
+                      <a:noFill/>
+                    </a:lnR>
+                    <a:lnT w="0" cap="flat" cmpd="sng" algn="ctr">
+                      <a:noFill/>
+                    </a:lnT>
+                    <a:lnB w="0" cap="flat" cmpd="sng" algn="ctr">
+                      <a:noFill/>
+                    </a:lnB>
+                    <a:solidFill>
+                      <a:srgbClr val="FFFFFF"/>
+                    </a:solidFill>
+                  </a:tcPr>
+                </a:tc>
+                <a:tc>
+                  <a:txBody>
+                    <a:bodyPr/>
+                    <a:lstStyle/>
+                    <a:p>
+                      <a:pPr indent="0" marL="0">
+                        <a:buNone/>
+                      </a:pPr>
+                      <a:r>
+                        <a:rPr lang="en-US" sz="800" i="1" dirty="0">
+                          <a:solidFill>
+                            <a:srgbClr val="808184"/>
+                          </a:solidFill>
+                          <a:latin typeface="Calibri" pitchFamily="34" charset="0"/>
+                          <a:ea typeface="Calibri" pitchFamily="34" charset="-122"/>
+                          <a:cs typeface="Calibri" pitchFamily="34" charset="-120"/>
+                        </a:rPr>
+                        <a:t>Roadmap</a:t>
+                      </a:r>
+                      <a:endParaRPr lang="en-US" sz="800" dirty="0">
+                        <a:latin typeface="Calibri" charset="0"/>
+                        <a:ea typeface="Calibri" charset="0"/>
+                        <a:cs typeface="Calibri" charset="0"/>
+                      </a:endParaRPr>
+                    </a:p>
+                  </a:txBody>
+                  <a:tcPr marL="91440" marR="91440" marT="45720" marB="45720" anchor="ctr">
+                    <a:lnL w="0" cap="flat" cmpd="sng" algn="ctr">
+                      <a:noFill/>
+                    </a:lnL>
+                    <a:lnR w="0" cap="flat" cmpd="sng" algn="ctr">
+                      <a:noFill/>
+                    </a:lnR>
+                    <a:lnT w="0" cap="flat" cmpd="sng" algn="ctr">
+                      <a:noFill/>
+                    </a:lnT>
+                    <a:lnB w="0" cap="flat" cmpd="sng" algn="ctr">
+                      <a:noFill/>
+                    </a:lnB>
+                    <a:solidFill>
+                      <a:srgbClr val="FFFFFF"/>
+                    </a:solidFill>
+                  </a:tcPr>
+                </a:tc>
+                <a:tc>
+                  <a:txBody>
+                    <a:bodyPr/>
+                    <a:lstStyle/>
+                    <a:p>
+                      <a:pPr indent="0" marL="0">
+                        <a:buNone/>
+                      </a:pPr>
+                      <a:r>
+                        <a:rPr lang="en-US" sz="800" dirty="0">
+                          <a:solidFill>
+                            <a:srgbClr val="58595B"/>
+                          </a:solidFill>
+                          <a:latin typeface="Calibri" pitchFamily="34" charset="0"/>
+                          <a:ea typeface="Calibri" pitchFamily="34" charset="-122"/>
+                          <a:cs typeface="Calibri" pitchFamily="34" charset="-120"/>
+                        </a:rPr>
+                        <a:t>Drafts an IF/THEN statement and severity for a new Business Rule.</a:t>
+                      </a:r>
+                      <a:endParaRPr lang="en-US" sz="800" dirty="0">
+                        <a:latin typeface="Calibri" charset="0"/>
+                        <a:ea typeface="Calibri" charset="0"/>
+                        <a:cs typeface="Calibri" charset="0"/>
+                      </a:endParaRPr>
+                    </a:p>
+                  </a:txBody>
+                  <a:tcPr marL="91440" marR="91440" marT="45720" marB="45720" anchor="ctr">
+                    <a:lnL w="0" cap="flat" cmpd="sng" algn="ctr">
+                      <a:noFill/>
+                    </a:lnL>
+                    <a:lnR w="0" cap="flat" cmpd="sng" algn="ctr">
+                      <a:noFill/>
+                    </a:lnR>
+                    <a:lnT w="0" cap="flat" cmpd="sng" algn="ctr">
+                      <a:noFill/>
+                    </a:lnT>
+                    <a:lnB w="0" cap="flat" cmpd="sng" algn="ctr">
+                      <a:noFill/>
+                    </a:lnB>
+                    <a:solidFill>
+                      <a:srgbClr val="FFFFFF"/>
+                    </a:solidFill>
+                  </a:tcPr>
+                </a:tc>
+              </a:tr>
+              <a:tr h="290779">
+                <a:tc>
+                  <a:txBody>
+                    <a:bodyPr/>
+                    <a:lstStyle/>
+                    <a:p>
+                      <a:pPr algn="ctr" indent="0" marL="0">
+                        <a:buNone/>
+                      </a:pPr>
+                      <a:r>
+                        <a:rPr lang="en-US" sz="800" dirty="0">
+                          <a:solidFill>
+                            <a:srgbClr val="808184"/>
+                          </a:solidFill>
+                          <a:latin typeface="Calibri" pitchFamily="34" charset="0"/>
+                          <a:ea typeface="Calibri" pitchFamily="34" charset="-122"/>
+                          <a:cs typeface="Calibri" pitchFamily="34" charset="-120"/>
+                        </a:rPr>
+                        <a:t>14</a:t>
+                      </a:r>
+                      <a:endParaRPr lang="en-US" sz="800" dirty="0">
+                        <a:latin typeface="Calibri" charset="0"/>
+                        <a:ea typeface="Calibri" charset="0"/>
+                        <a:cs typeface="Calibri" charset="0"/>
+                      </a:endParaRPr>
+                    </a:p>
+                  </a:txBody>
+                  <a:tcPr marL="91440" marR="91440" marT="45720" marB="45720" anchor="ctr">
+                    <a:lnL w="0" cap="flat" cmpd="sng" algn="ctr">
+                      <a:noFill/>
+                    </a:lnL>
+                    <a:lnR w="0" cap="flat" cmpd="sng" algn="ctr">
+                      <a:noFill/>
+                    </a:lnR>
+                    <a:lnT w="0" cap="flat" cmpd="sng" algn="ctr">
+                      <a:noFill/>
+                    </a:lnT>
+                    <a:lnB w="0" cap="flat" cmpd="sng" algn="ctr">
+                      <a:noFill/>
+                    </a:lnB>
+                    <a:solidFill>
+                      <a:srgbClr val="F2F2F3"/>
+                    </a:solidFill>
+                  </a:tcPr>
+                </a:tc>
+                <a:tc>
+                  <a:txBody>
+                    <a:bodyPr/>
+                    <a:lstStyle/>
+                    <a:p>
+                      <a:pPr indent="0" marL="0">
+                        <a:buNone/>
+                      </a:pPr>
+                      <a:r>
+                        <a:rPr lang="en-US" sz="800" b="1" dirty="0">
+                          <a:solidFill>
+                            <a:srgbClr val="3A3A3C"/>
+                          </a:solidFill>
+                          <a:latin typeface="Calibri" pitchFamily="34" charset="0"/>
+                          <a:ea typeface="Calibri" pitchFamily="34" charset="-122"/>
+                          <a:cs typeface="Calibri" pitchFamily="34" charset="-120"/>
+                        </a:rPr>
+                        <a:t>RACSI Assignment Recommendation Assistant</a:t>
+                      </a:r>
+                      <a:endParaRPr lang="en-US" sz="800" dirty="0">
+                        <a:latin typeface="Calibri" charset="0"/>
+                        <a:ea typeface="Calibri" charset="0"/>
+                        <a:cs typeface="Calibri" charset="0"/>
+                      </a:endParaRPr>
+                    </a:p>
+                  </a:txBody>
+                  <a:tcPr marL="91440" marR="91440" marT="45720" marB="45720" anchor="ctr">
+                    <a:lnL w="0" cap="flat" cmpd="sng" algn="ctr">
+                      <a:noFill/>
+                    </a:lnL>
+                    <a:lnR w="0" cap="flat" cmpd="sng" algn="ctr">
+                      <a:noFill/>
+                    </a:lnR>
+                    <a:lnT w="0" cap="flat" cmpd="sng" algn="ctr">
+                      <a:noFill/>
+                    </a:lnT>
+                    <a:lnB w="0" cap="flat" cmpd="sng" algn="ctr">
+                      <a:noFill/>
+                    </a:lnB>
+                    <a:solidFill>
+                      <a:srgbClr val="F2F2F3"/>
+                    </a:solidFill>
+                  </a:tcPr>
+                </a:tc>
+                <a:tc>
+                  <a:txBody>
+                    <a:bodyPr/>
+                    <a:lstStyle/>
+                    <a:p>
+                      <a:pPr indent="0" marL="0">
+                        <a:buNone/>
+                      </a:pPr>
+                      <a:r>
+                        <a:rPr lang="en-US" sz="800" dirty="0">
+                          <a:solidFill>
+                            <a:srgbClr val="58595B"/>
+                          </a:solidFill>
+                          <a:latin typeface="Calibri" pitchFamily="34" charset="0"/>
+                          <a:ea typeface="Calibri" pitchFamily="34" charset="-122"/>
+                          <a:cs typeface="Calibri" pitchFamily="34" charset="-120"/>
+                        </a:rPr>
+                        <a:t>Assistive</a:t>
+                      </a:r>
+                      <a:endParaRPr lang="en-US" sz="800" dirty="0">
+                        <a:latin typeface="Calibri" charset="0"/>
+                        <a:ea typeface="Calibri" charset="0"/>
+                        <a:cs typeface="Calibri" charset="0"/>
+                      </a:endParaRPr>
+                    </a:p>
+                  </a:txBody>
+                  <a:tcPr marL="91440" marR="91440" marT="45720" marB="45720" anchor="ctr">
+                    <a:lnL w="0" cap="flat" cmpd="sng" algn="ctr">
+                      <a:noFill/>
+                    </a:lnL>
+                    <a:lnR w="0" cap="flat" cmpd="sng" algn="ctr">
+                      <a:noFill/>
+                    </a:lnR>
+                    <a:lnT w="0" cap="flat" cmpd="sng" algn="ctr">
+                      <a:noFill/>
+                    </a:lnT>
+                    <a:lnB w="0" cap="flat" cmpd="sng" algn="ctr">
+                      <a:noFill/>
+                    </a:lnB>
+                    <a:solidFill>
+                      <a:srgbClr val="F2F2F3"/>
+                    </a:solidFill>
+                  </a:tcPr>
+                </a:tc>
+                <a:tc>
+                  <a:txBody>
+                    <a:bodyPr/>
+                    <a:lstStyle/>
+                    <a:p>
+                      <a:pPr indent="0" marL="0">
+                        <a:buNone/>
+                      </a:pPr>
+                      <a:r>
+                        <a:rPr lang="en-US" sz="800" dirty="0">
+                          <a:solidFill>
+                            <a:srgbClr val="58595B"/>
+                          </a:solidFill>
+                          <a:latin typeface="Calibri" pitchFamily="34" charset="0"/>
+                          <a:ea typeface="Calibri" pitchFamily="34" charset="-122"/>
+                          <a:cs typeface="Calibri" pitchFamily="34" charset="-120"/>
+                        </a:rPr>
+                        <a:t>RACSI</a:t>
+                      </a:r>
+                      <a:endParaRPr lang="en-US" sz="800" dirty="0">
+                        <a:latin typeface="Calibri" charset="0"/>
+                        <a:ea typeface="Calibri" charset="0"/>
+                        <a:cs typeface="Calibri" charset="0"/>
+                      </a:endParaRPr>
+                    </a:p>
+                  </a:txBody>
+                  <a:tcPr marL="91440" marR="91440" marT="45720" marB="45720" anchor="ctr">
+                    <a:lnL w="0" cap="flat" cmpd="sng" algn="ctr">
+                      <a:noFill/>
+                    </a:lnL>
+                    <a:lnR w="0" cap="flat" cmpd="sng" algn="ctr">
+                      <a:noFill/>
+                    </a:lnR>
+                    <a:lnT w="0" cap="flat" cmpd="sng" algn="ctr">
+                      <a:noFill/>
+                    </a:lnT>
+                    <a:lnB w="0" cap="flat" cmpd="sng" algn="ctr">
+                      <a:noFill/>
+                    </a:lnB>
+                    <a:solidFill>
+                      <a:srgbClr val="F2F2F3"/>
+                    </a:solidFill>
+                  </a:tcPr>
+                </a:tc>
+                <a:tc>
+                  <a:txBody>
+                    <a:bodyPr/>
+                    <a:lstStyle/>
+                    <a:p>
+                      <a:pPr indent="0" marL="0">
+                        <a:buNone/>
+                      </a:pPr>
+                      <a:r>
+                        <a:rPr lang="en-US" sz="800" i="1" dirty="0">
+                          <a:solidFill>
+                            <a:srgbClr val="808184"/>
+                          </a:solidFill>
+                          <a:latin typeface="Calibri" pitchFamily="34" charset="0"/>
+                          <a:ea typeface="Calibri" pitchFamily="34" charset="-122"/>
+                          <a:cs typeface="Calibri" pitchFamily="34" charset="-120"/>
+                        </a:rPr>
+                        <a:t>Roadmap</a:t>
+                      </a:r>
+                      <a:endParaRPr lang="en-US" sz="800" dirty="0">
+                        <a:latin typeface="Calibri" charset="0"/>
+                        <a:ea typeface="Calibri" charset="0"/>
+                        <a:cs typeface="Calibri" charset="0"/>
+                      </a:endParaRPr>
+                    </a:p>
+                  </a:txBody>
+                  <a:tcPr marL="91440" marR="91440" marT="45720" marB="45720" anchor="ctr">
+                    <a:lnL w="0" cap="flat" cmpd="sng" algn="ctr">
+                      <a:noFill/>
+                    </a:lnL>
+                    <a:lnR w="0" cap="flat" cmpd="sng" algn="ctr">
+                      <a:noFill/>
+                    </a:lnR>
+                    <a:lnT w="0" cap="flat" cmpd="sng" algn="ctr">
+                      <a:noFill/>
+                    </a:lnT>
+                    <a:lnB w="0" cap="flat" cmpd="sng" algn="ctr">
+                      <a:noFill/>
+                    </a:lnB>
+                    <a:solidFill>
+                      <a:srgbClr val="F2F2F3"/>
+                    </a:solidFill>
+                  </a:tcPr>
+                </a:tc>
+                <a:tc>
+                  <a:txBody>
+                    <a:bodyPr/>
+                    <a:lstStyle/>
+                    <a:p>
+                      <a:pPr indent="0" marL="0">
+                        <a:buNone/>
+                      </a:pPr>
+                      <a:r>
+                        <a:rPr lang="en-US" sz="800" dirty="0">
+                          <a:solidFill>
+                            <a:srgbClr val="58595B"/>
+                          </a:solidFill>
+                          <a:latin typeface="Calibri" pitchFamily="34" charset="0"/>
+                          <a:ea typeface="Calibri" pitchFamily="34" charset="-122"/>
+                          <a:cs typeface="Calibri" pitchFamily="34" charset="-120"/>
+                        </a:rPr>
+                        <a:t>Suggests Accountable/Responsible/Consulted/Support/Informed assignees for a new Activity.</a:t>
+                      </a:r>
+                      <a:endParaRPr lang="en-US" sz="800" dirty="0">
+                        <a:latin typeface="Calibri" charset="0"/>
+                        <a:ea typeface="Calibri" charset="0"/>
+                        <a:cs typeface="Calibri" charset="0"/>
+                      </a:endParaRPr>
+                    </a:p>
+                  </a:txBody>
+                  <a:tcPr marL="91440" marR="91440" marT="45720" marB="45720" anchor="ctr">
+                    <a:lnL w="0" cap="flat" cmpd="sng" algn="ctr">
+                      <a:noFill/>
+                    </a:lnL>
+                    <a:lnR w="0" cap="flat" cmpd="sng" algn="ctr">
+                      <a:noFill/>
+                    </a:lnR>
+                    <a:lnT w="0" cap="flat" cmpd="sng" algn="ctr">
+                      <a:noFill/>
+                    </a:lnT>
+                    <a:lnB w="0" cap="flat" cmpd="sng" algn="ctr">
+                      <a:noFill/>
+                    </a:lnB>
+                    <a:solidFill>
+                      <a:srgbClr val="F2F2F3"/>
+                    </a:solidFill>
+                  </a:tcPr>
+                </a:tc>
+              </a:tr>
+            </a:tbl>
+          </a:graphicData>
+        </a:graphic>
+      </p:graphicFrame>
+      <p:pic>
+        <p:nvPicPr>
+          <p:cNvPr id="5" name="Image 0" descr="/tmp/pptx-work/brand_media/image1.png">    </p:cNvPr>
+          <p:cNvPicPr>
+            <a:picLocks noChangeAspect="1"/>
+          </p:cNvPicPr>
+          <p:nvPr/>
+        </p:nvPicPr>
+        <p:blipFill>
+          <a:blip r:embed="rId1"/>
+          <a:stretch>
+            <a:fillRect/>
+          </a:stretch>
+        </p:blipFill>
+        <p:spPr>
+          <a:xfrm>
+            <a:off x="548640" y="6473952"/>
+            <a:ext cx="685800" cy="220094"/>
+          </a:xfrm>
+          <a:prstGeom prst="rect">
+            <a:avLst/>
+          </a:prstGeom>
+        </p:spPr>
+      </p:pic>
+      <p:sp>
+        <p:nvSpPr>
+          <p:cNvPr id="6" name="Text 2"/>
+          <p:cNvSpPr txBox="1"/>
+          <p:nvPr/>
+        </p:nvSpPr>
+        <p:spPr>
+          <a:xfrm>
+            <a:off x="3931920" y="6464808"/>
+            <a:ext cx="4572000" cy="274320"/>
+          </a:xfrm>
+          <a:prstGeom prst="rect">
+            <a:avLst/>
+          </a:prstGeom>
+          <a:noFill/>
+          <a:ln/>
+        </p:spPr>
+        <p:txBody>
+          <a:bodyPr wrap="square" lIns="0" tIns="0" rIns="0" bIns="0" rtlCol="0" anchor="ctr"/>
+          <a:lstStyle/>
+          <a:p>
+            <a:pPr algn="ctr" indent="0" marL="0">
+              <a:buNone/>
+            </a:pPr>
+            <a:r>
+              <a:rPr lang="en-US" sz="900" dirty="0">
+                <a:solidFill>
+                  <a:srgbClr val="808184"/>
+                </a:solidFill>
+                <a:latin typeface="Calibri" pitchFamily="34" charset="0"/>
+                <a:ea typeface="Calibri" pitchFamily="34" charset="-122"/>
+                <a:cs typeface="Calibri" pitchFamily="34" charset="-120"/>
+              </a:rPr>
+              <a:t>The Governed AI Use Case Library</a:t>
+            </a:r>
+            <a:endParaRPr lang="en-US" sz="900" dirty="0"/>
+          </a:p>
+        </p:txBody>
+      </p:sp>
+      <p:sp>
+        <p:nvSpPr>
+          <p:cNvPr id="7" name="Text 3"/>
+          <p:cNvSpPr txBox="1"/>
+          <p:nvPr/>
+        </p:nvSpPr>
+        <p:spPr>
+          <a:xfrm>
+            <a:off x="11430000" y="6464808"/>
+            <a:ext cx="274320" cy="274320"/>
+          </a:xfrm>
+          <a:prstGeom prst="rect">
+            <a:avLst/>
+          </a:prstGeom>
+          <a:noFill/>
+          <a:ln/>
+        </p:spPr>
+        <p:txBody>
+          <a:bodyPr wrap="square" lIns="0" tIns="0" rIns="0" bIns="0" rtlCol="0" anchor="ctr"/>
+          <a:lstStyle/>
+          <a:p>
+            <a:pPr algn="r" indent="0" marL="0">
+              <a:buNone/>
+            </a:pPr>
+            <a:r>
+              <a:rPr lang="en-US" sz="900" dirty="0">
+                <a:solidFill>
+                  <a:srgbClr val="808184"/>
+                </a:solidFill>
+                <a:latin typeface="Calibri" pitchFamily="34" charset="0"/>
+                <a:ea typeface="Calibri" pitchFamily="34" charset="-122"/>
+                <a:cs typeface="Calibri" pitchFamily="34" charset="-120"/>
+              </a:rPr>
+              <a:t>3</a:t>
+            </a:r>
+            <a:endParaRPr lang="en-US" sz="900" dirty="0"/>
+          </a:p>
+        </p:txBody>
+      </p:sp>
+    </p:spTree>
+  </p:cSld>
+  <p:clrMapOvr>
+    <a:masterClrMapping/>
+  </p:clrMapOvr>
+</p:sld>
+</file>
+
+<file path=ppt/slides/slide4.xml><?xml version="1.0" encoding="utf-8"?>
+<p:sld xmlns:a="http://schemas.openxmlformats.org/drawingml/2006/main" xmlns:r="http://schemas.openxmlformats.org/officeDocument/2006/relationships" xmlns:p="http://schemas.openxmlformats.org/presentationml/2006/main">
+  <p:cSld name="Slide 4">
+    <p:bg>
+      <p:bgPr>
+        <a:solidFill>
           <a:srgbClr val="3A3A3C"/>
         </a:solidFill>
       </p:bgPr>

</xml_diff>